<commit_message>
Rebuild the marketing kit and film with Vixl 0.20.0
Recount the copy facts from the 0.20.0 registries (179 operations, 47
layouts, 40 templates, 17 looks, 10,000-op batches) and update claims,
fix the layout issues the 0.20.0 deck/phone check profiles found, and
drop the contact-sheet workaround (fixed in 0.20.0). Re-render The Germ
King with one atomic batch per scene and note the 24 kHz audio limit.
Ignore .vixl-cache.usage.json.

Co-Authored-By: Claude Opus 5.5 <noreply@anthropic.com>
Claude-Session: https://claude.ai/code/session_014NqAoPUDZ9CN18Yp3vYbtS
</commit_message>
<xml_diff>
--- a/marketing/output/deck/vixl-pitch-deck.pptx
+++ b/marketing/output/deck/vixl-pitch-deck.pptx
@@ -461,7 +461,7 @@
           <a:p>
             <a:r>
               <a:rPr lang="en-US" dirty="0"/>
-              <a:t>Real timings from the exploration projects, before and after the performance fixes.</a:t>
+              <a:t>Real timings from the exploration projects, before and after the 0.18.0 performance fixes.</a:t>
             </a:r>
           </a:p>
         </p:txBody>
@@ -579,7 +579,7 @@
           <a:p>
             <a:r>
               <a:rPr lang="en-US" dirty="0"/>
-              <a:t>One master, every format. CMYK print and editable PowerPoint included.</a:t>
+              <a:t>One master, every format. CMYK print, editable PowerPoint and mixed WAV audio included.</a:t>
             </a:r>
           </a:p>
         </p:txBody>
@@ -1039,8 +1039,8 @@
         </p:nvSpPr>
         <p:spPr>
           <a:xfrm>
-            <a:off x="871141" y="5280633"/>
-            <a:ext cx="5151438" cy="269267"/>
+            <a:off x="889000" y="5280620"/>
+            <a:ext cx="5246688" cy="269280"/>
           </a:xfrm>
           <a:prstGeom prst="rect">
             <a:avLst/>
@@ -1068,7 +1068,7 @@
                 <a:ea typeface="Inter"/>
                 <a:cs typeface="Inter"/>
               </a:rPr>
-              <a:t>Release 0.19.0  ·  MCP · CLI · Python · REST</a:t>
+              <a:t>Release 0.20.0  ·  MCP · CLI · Python · REST</a:t>
             </a:r>
             <a:endParaRPr lang="en-US" sz="1600" dirty="0"/>
           </a:p>
@@ -1166,8 +1166,8 @@
         </p:nvSpPr>
         <p:spPr>
           <a:xfrm>
-            <a:off x="11102594" y="6180328"/>
-            <a:ext cx="311150" cy="182372"/>
+            <a:off x="11112500" y="6180328"/>
+            <a:ext cx="323850" cy="182372"/>
           </a:xfrm>
           <a:prstGeom prst="rect">
             <a:avLst/>
@@ -1209,8 +1209,8 @@
         </p:nvSpPr>
         <p:spPr>
           <a:xfrm>
-            <a:off x="880580" y="563372"/>
-            <a:ext cx="1357312" cy="198628"/>
+            <a:off x="889000" y="563372"/>
+            <a:ext cx="1365250" cy="198628"/>
           </a:xfrm>
           <a:prstGeom prst="rect">
             <a:avLst/>
@@ -1366,8 +1366,8 @@
         </p:nvSpPr>
         <p:spPr>
           <a:xfrm>
-            <a:off x="1161653" y="3089870"/>
-            <a:ext cx="520700" cy="224830"/>
+            <a:off x="1168400" y="3089870"/>
+            <a:ext cx="533400" cy="224830"/>
           </a:xfrm>
           <a:prstGeom prst="rect">
             <a:avLst/>
@@ -1409,8 +1409,8 @@
         </p:nvSpPr>
         <p:spPr>
           <a:xfrm>
-            <a:off x="1157436" y="3453892"/>
-            <a:ext cx="2082800" cy="413258"/>
+            <a:off x="1168400" y="3453892"/>
+            <a:ext cx="2095500" cy="413258"/>
           </a:xfrm>
           <a:prstGeom prst="rect">
             <a:avLst/>
@@ -1525,8 +1525,8 @@
         </p:nvSpPr>
         <p:spPr>
           <a:xfrm>
-            <a:off x="4717653" y="3089870"/>
-            <a:ext cx="565150" cy="224830"/>
+            <a:off x="4724400" y="3089870"/>
+            <a:ext cx="571500" cy="224830"/>
           </a:xfrm>
           <a:prstGeom prst="rect">
             <a:avLst/>
@@ -1568,8 +1568,8 @@
         </p:nvSpPr>
         <p:spPr>
           <a:xfrm>
-            <a:off x="4710857" y="3438252"/>
-            <a:ext cx="1962150" cy="352698"/>
+            <a:off x="4724400" y="3438252"/>
+            <a:ext cx="1974850" cy="352698"/>
           </a:xfrm>
           <a:prstGeom prst="rect">
             <a:avLst/>
@@ -1684,8 +1684,8 @@
         </p:nvSpPr>
         <p:spPr>
           <a:xfrm>
-            <a:off x="8273653" y="3089870"/>
-            <a:ext cx="571500" cy="224830"/>
+            <a:off x="8280400" y="3089870"/>
+            <a:ext cx="577850" cy="224830"/>
           </a:xfrm>
           <a:prstGeom prst="rect">
             <a:avLst/>
@@ -1727,8 +1727,8 @@
         </p:nvSpPr>
         <p:spPr>
           <a:xfrm>
-            <a:off x="8266857" y="3438252"/>
-            <a:ext cx="2254250" cy="352698"/>
+            <a:off x="8280400" y="3438252"/>
+            <a:ext cx="2266950" cy="352698"/>
           </a:xfrm>
           <a:prstGeom prst="rect">
             <a:avLst/>
@@ -1903,8 +1903,8 @@
         </p:nvSpPr>
         <p:spPr>
           <a:xfrm>
-            <a:off x="11102594" y="6178804"/>
-            <a:ext cx="311150" cy="183896"/>
+            <a:off x="11112500" y="6178804"/>
+            <a:ext cx="323850" cy="183896"/>
           </a:xfrm>
           <a:prstGeom prst="rect">
             <a:avLst/>
@@ -1946,8 +1946,8 @@
         </p:nvSpPr>
         <p:spPr>
           <a:xfrm>
-            <a:off x="880580" y="563537"/>
-            <a:ext cx="1476375" cy="198463"/>
+            <a:off x="889000" y="563537"/>
+            <a:ext cx="1492250" cy="198463"/>
           </a:xfrm>
           <a:prstGeom prst="rect">
             <a:avLst/>
@@ -2185,8 +2185,8 @@
           </p:nvSpPr>
           <p:spPr>
             <a:xfrm>
-              <a:off x="624599" y="57163"/>
-              <a:ext cx="1087438" cy="190487"/>
+              <a:off x="635000" y="57163"/>
+              <a:ext cx="1103312" cy="190487"/>
             </a:xfrm>
             <a:prstGeom prst="rect">
               <a:avLst/>
@@ -2717,8 +2717,8 @@
         </p:nvSpPr>
         <p:spPr>
           <a:xfrm>
-            <a:off x="1149424" y="2965202"/>
-            <a:ext cx="6254750" cy="285998"/>
+            <a:off x="1168400" y="2962988"/>
+            <a:ext cx="6992938" cy="281862"/>
           </a:xfrm>
           <a:prstGeom prst="rect">
             <a:avLst/>
@@ -2746,7 +2746,7 @@
                 <a:ea typeface="Inter"/>
                 <a:cs typeface="Inter"/>
               </a:rPr>
-              <a:t>Editable .vixl masters: text, masks, effects, pages</a:t>
+              <a:t>Editable .vixl masters: text, vector paths, masks, pages</a:t>
             </a:r>
             <a:endParaRPr lang="en-US" sz="1700" dirty="0"/>
           </a:p>
@@ -2782,8 +2782,8 @@
         </p:nvSpPr>
         <p:spPr>
           <a:xfrm>
-            <a:off x="1158280" y="3597988"/>
-            <a:ext cx="4770438" cy="281862"/>
+            <a:off x="1168400" y="3597988"/>
+            <a:ext cx="5818188" cy="281862"/>
           </a:xfrm>
           <a:prstGeom prst="rect">
             <a:avLst/>
@@ -2811,7 +2811,7 @@
                 <a:ea typeface="Inter"/>
                 <a:cs typeface="Inter"/>
               </a:rPr>
-              <a:t>138 operations, applied all-or-nothing</a:t>
+              <a:t>179 operations, up to 10,000 per atomic batch</a:t>
             </a:r>
             <a:endParaRPr lang="en-US" sz="1700" dirty="0"/>
           </a:p>
@@ -2847,8 +2847,8 @@
         </p:nvSpPr>
         <p:spPr>
           <a:xfrm>
-            <a:off x="1156171" y="4232988"/>
-            <a:ext cx="4413250" cy="281862"/>
+            <a:off x="1168400" y="4232988"/>
+            <a:ext cx="4429125" cy="281862"/>
           </a:xfrm>
           <a:prstGeom prst="rect">
             <a:avLst/>
@@ -2912,8 +2912,8 @@
         </p:nvSpPr>
         <p:spPr>
           <a:xfrm>
-            <a:off x="1149424" y="4870202"/>
-            <a:ext cx="4905375" cy="279648"/>
+            <a:off x="1168400" y="4870202"/>
+            <a:ext cx="4929188" cy="279648"/>
           </a:xfrm>
           <a:prstGeom prst="rect">
             <a:avLst/>
@@ -3039,8 +3039,8 @@
         </p:nvSpPr>
         <p:spPr>
           <a:xfrm>
-            <a:off x="11101375" y="6178804"/>
-            <a:ext cx="311150" cy="183896"/>
+            <a:off x="11112500" y="6178804"/>
+            <a:ext cx="323850" cy="183896"/>
           </a:xfrm>
           <a:prstGeom prst="rect">
             <a:avLst/>
@@ -3082,8 +3082,8 @@
         </p:nvSpPr>
         <p:spPr>
           <a:xfrm>
-            <a:off x="874967" y="563537"/>
-            <a:ext cx="1468438" cy="198463"/>
+            <a:off x="889000" y="563537"/>
+            <a:ext cx="1492250" cy="198463"/>
           </a:xfrm>
           <a:prstGeom prst="rect">
             <a:avLst/>
@@ -3213,8 +3213,8 @@
         </p:nvSpPr>
         <p:spPr>
           <a:xfrm>
-            <a:off x="1047564" y="2475390"/>
-            <a:ext cx="504825" cy="223360"/>
+            <a:off x="1054100" y="2475390"/>
+            <a:ext cx="511175" cy="223360"/>
           </a:xfrm>
           <a:prstGeom prst="rect">
             <a:avLst/>
@@ -3256,8 +3256,8 @@
         </p:nvSpPr>
         <p:spPr>
           <a:xfrm>
-            <a:off x="1042640" y="2758356"/>
-            <a:ext cx="1397000" cy="353144"/>
+            <a:off x="1054100" y="2760896"/>
+            <a:ext cx="1409700" cy="353144"/>
           </a:xfrm>
           <a:prstGeom prst="rect">
             <a:avLst/>
@@ -3424,8 +3424,8 @@
         </p:nvSpPr>
         <p:spPr>
           <a:xfrm>
-            <a:off x="3155764" y="2475390"/>
-            <a:ext cx="549275" cy="223360"/>
+            <a:off x="3162300" y="2475390"/>
+            <a:ext cx="555625" cy="223360"/>
           </a:xfrm>
           <a:prstGeom prst="rect">
             <a:avLst/>
@@ -3467,7 +3467,7 @@
         </p:nvSpPr>
         <p:spPr>
           <a:xfrm>
-            <a:off x="3159844" y="2758356"/>
+            <a:off x="3162300" y="2760896"/>
             <a:ext cx="1200150" cy="353144"/>
           </a:xfrm>
           <a:prstGeom prst="rect">
@@ -3545,7 +3545,7 @@
                 <a:ea typeface="Inter"/>
                 <a:cs typeface="Inter"/>
               </a:rPr>
-              <a:t>Atomic batches of operations</a:t>
+              <a:t>Atomic batches, up to 10,000 ops</a:t>
             </a:r>
             <a:endParaRPr lang="en-US" sz="1200" dirty="0"/>
           </a:p>
@@ -3635,8 +3635,8 @@
         </p:nvSpPr>
         <p:spPr>
           <a:xfrm>
-            <a:off x="5263964" y="2475390"/>
-            <a:ext cx="549275" cy="223360"/>
+            <a:off x="5270500" y="2475390"/>
+            <a:ext cx="555625" cy="223360"/>
           </a:xfrm>
           <a:prstGeom prst="rect">
             <a:avLst/>
@@ -3678,8 +3678,8 @@
         </p:nvSpPr>
         <p:spPr>
           <a:xfrm>
-            <a:off x="5261223" y="2761084"/>
-            <a:ext cx="1270000" cy="299616"/>
+            <a:off x="5270500" y="2763624"/>
+            <a:ext cx="1276350" cy="299616"/>
           </a:xfrm>
           <a:prstGeom prst="rect">
             <a:avLst/>
@@ -3846,8 +3846,8 @@
         </p:nvSpPr>
         <p:spPr>
           <a:xfrm>
-            <a:off x="7372164" y="2475390"/>
-            <a:ext cx="555625" cy="223360"/>
+            <a:off x="7378700" y="2475390"/>
+            <a:ext cx="561975" cy="223360"/>
           </a:xfrm>
           <a:prstGeom prst="rect">
             <a:avLst/>
@@ -3889,8 +3889,8 @@
         </p:nvSpPr>
         <p:spPr>
           <a:xfrm>
-            <a:off x="7367240" y="2771589"/>
-            <a:ext cx="1460500" cy="301811"/>
+            <a:off x="7378700" y="2774129"/>
+            <a:ext cx="1473200" cy="301811"/>
           </a:xfrm>
           <a:prstGeom prst="rect">
             <a:avLst/>
@@ -4057,8 +4057,8 @@
         </p:nvSpPr>
         <p:spPr>
           <a:xfrm>
-            <a:off x="9480364" y="2475390"/>
-            <a:ext cx="549275" cy="223360"/>
+            <a:off x="9486900" y="2475390"/>
+            <a:ext cx="555625" cy="223360"/>
           </a:xfrm>
           <a:prstGeom prst="rect">
             <a:avLst/>
@@ -4100,8 +4100,8 @@
         </p:nvSpPr>
         <p:spPr>
           <a:xfrm>
-            <a:off x="9475440" y="2758356"/>
-            <a:ext cx="1289050" cy="353144"/>
+            <a:off x="9486900" y="2760896"/>
+            <a:ext cx="1295400" cy="353144"/>
           </a:xfrm>
           <a:prstGeom prst="rect">
             <a:avLst/>
@@ -4325,8 +4325,8 @@
         </p:nvSpPr>
         <p:spPr>
           <a:xfrm>
-            <a:off x="11100613" y="6178804"/>
-            <a:ext cx="311150" cy="183896"/>
+            <a:off x="11112500" y="6178804"/>
+            <a:ext cx="323850" cy="183896"/>
           </a:xfrm>
           <a:prstGeom prst="rect">
             <a:avLst/>
@@ -4368,8 +4368,8 @@
         </p:nvSpPr>
         <p:spPr>
           <a:xfrm>
-            <a:off x="878103" y="561886"/>
-            <a:ext cx="1722438" cy="200114"/>
+            <a:off x="889000" y="561886"/>
+            <a:ext cx="1738312" cy="200114"/>
           </a:xfrm>
           <a:prstGeom prst="rect">
             <a:avLst/>
@@ -4859,10 +4859,10 @@
         </p:nvGrpSpPr>
         <p:grpSpPr>
           <a:xfrm>
-            <a:off x="977900" y="3562350"/>
-            <a:ext cx="939800" cy="254000"/>
+            <a:off x="977900" y="3549650"/>
+            <a:ext cx="1022350" cy="266700"/>
             <a:chOff x="0" y="0"/>
-            <a:chExt cx="939800" cy="254000"/>
+            <a:chExt cx="1022350" cy="266700"/>
           </a:xfrm>
         </p:grpSpPr>
         <p:sp>
@@ -4874,7 +4874,7 @@
           <p:spPr>
             <a:xfrm>
               <a:off x="0" y="0"/>
-              <a:ext cx="939800" cy="254000"/>
+              <a:ext cx="1022350" cy="266700"/>
             </a:xfrm>
             <a:prstGeom prst="roundRect">
               <a:avLst>
@@ -4899,8 +4899,8 @@
           </p:nvSpPr>
           <p:spPr>
             <a:xfrm>
-              <a:off x="104998" y="30919"/>
-              <a:ext cx="901700" cy="178631"/>
+              <a:off x="114300" y="28804"/>
+              <a:ext cx="1003300" cy="193954"/>
             </a:xfrm>
             <a:prstGeom prst="rect">
               <a:avLst/>
@@ -4915,12 +4915,12 @@
             <a:p>
               <a:pPr algn="l">
                 <a:lnSpc>
-                  <a:spcPts val="1410"/>
+                  <a:spcPts val="1531"/>
                 </a:lnSpc>
                 <a:buNone/>
               </a:pPr>
               <a:r>
-                <a:rPr lang="en-US" sz="1000" dirty="0">
+                <a:rPr lang="en-US" sz="1100" dirty="0">
                   <a:solidFill>
                     <a:srgbClr val="FFFFFF"/>
                   </a:solidFill>
@@ -4930,7 +4930,7 @@
                 </a:rPr>
                 <a:t>Print poster</a:t>
               </a:r>
-              <a:endParaRPr lang="en-US" sz="1000" dirty="0"/>
+              <a:endParaRPr lang="en-US" sz="1100" dirty="0"/>
             </a:p>
           </p:txBody>
         </p:sp>
@@ -4943,10 +4943,10 @@
         </p:nvGrpSpPr>
         <p:grpSpPr>
           <a:xfrm>
-            <a:off x="3625850" y="3562350"/>
-            <a:ext cx="1428750" cy="254000"/>
+            <a:off x="3625850" y="3549650"/>
+            <a:ext cx="1555750" cy="266700"/>
             <a:chOff x="0" y="0"/>
-            <a:chExt cx="1428750" cy="254000"/>
+            <a:chExt cx="1555750" cy="266700"/>
           </a:xfrm>
         </p:grpSpPr>
         <p:sp>
@@ -4958,7 +4958,7 @@
           <p:spPr>
             <a:xfrm>
               <a:off x="0" y="0"/>
-              <a:ext cx="1428750" cy="254000"/>
+              <a:ext cx="1555750" cy="266700"/>
             </a:xfrm>
             <a:prstGeom prst="roundRect">
               <a:avLst>
@@ -4983,8 +4983,8 @@
           </p:nvSpPr>
           <p:spPr>
             <a:xfrm>
-              <a:off x="107913" y="30919"/>
-              <a:ext cx="1500188" cy="178631"/>
+              <a:off x="114300" y="28804"/>
+              <a:ext cx="1658938" cy="193954"/>
             </a:xfrm>
             <a:prstGeom prst="rect">
               <a:avLst/>
@@ -4999,12 +4999,12 @@
             <a:p>
               <a:pPr algn="l">
                 <a:lnSpc>
-                  <a:spcPts val="1410"/>
+                  <a:spcPts val="1531"/>
                 </a:lnSpc>
                 <a:buNone/>
               </a:pPr>
               <a:r>
-                <a:rPr lang="en-US" sz="1000" dirty="0">
+                <a:rPr lang="en-US" sz="1100" dirty="0">
                   <a:solidFill>
                     <a:srgbClr val="FFFFFF"/>
                   </a:solidFill>
@@ -5014,7 +5014,7 @@
                 </a:rPr>
                 <a:t>Generative painting</a:t>
               </a:r>
-              <a:endParaRPr lang="en-US" sz="1000" dirty="0"/>
+              <a:endParaRPr lang="en-US" sz="1100" dirty="0"/>
             </a:p>
           </p:txBody>
         </p:sp>
@@ -5027,10 +5027,10 @@
         </p:nvGrpSpPr>
         <p:grpSpPr>
           <a:xfrm>
-            <a:off x="6273800" y="3562350"/>
-            <a:ext cx="1117600" cy="254000"/>
+            <a:off x="6273800" y="3549650"/>
+            <a:ext cx="1219200" cy="266700"/>
             <a:chOff x="0" y="0"/>
-            <a:chExt cx="1117600" cy="254000"/>
+            <a:chExt cx="1219200" cy="266700"/>
           </a:xfrm>
         </p:grpSpPr>
         <p:sp>
@@ -5042,7 +5042,7 @@
           <p:spPr>
             <a:xfrm>
               <a:off x="0" y="0"/>
-              <a:ext cx="1117600" cy="254000"/>
+              <a:ext cx="1219200" cy="266700"/>
             </a:xfrm>
             <a:prstGeom prst="roundRect">
               <a:avLst>
@@ -5067,8 +5067,8 @@
           </p:nvSpPr>
           <p:spPr>
             <a:xfrm>
-              <a:off x="104998" y="30919"/>
-              <a:ext cx="1111250" cy="178631"/>
+              <a:off x="114300" y="28804"/>
+              <a:ext cx="1238250" cy="193954"/>
             </a:xfrm>
             <a:prstGeom prst="rect">
               <a:avLst/>
@@ -5083,12 +5083,12 @@
             <a:p>
               <a:pPr algn="l">
                 <a:lnSpc>
-                  <a:spcPts val="1410"/>
+                  <a:spcPts val="1531"/>
                 </a:lnSpc>
                 <a:buNone/>
               </a:pPr>
               <a:r>
-                <a:rPr lang="en-US" sz="1000" dirty="0">
+                <a:rPr lang="en-US" sz="1100" dirty="0">
                   <a:solidFill>
                     <a:srgbClr val="FFFFFF"/>
                   </a:solidFill>
@@ -5098,7 +5098,7 @@
                 </a:rPr>
                 <a:t>Pixel-art game</a:t>
               </a:r>
-              <a:endParaRPr lang="en-US" sz="1000" dirty="0"/>
+              <a:endParaRPr lang="en-US" sz="1100" dirty="0"/>
             </a:p>
           </p:txBody>
         </p:sp>
@@ -5111,10 +5111,10 @@
         </p:nvGrpSpPr>
         <p:grpSpPr>
           <a:xfrm>
-            <a:off x="8921750" y="3562350"/>
-            <a:ext cx="1238250" cy="254000"/>
+            <a:off x="8921750" y="3549650"/>
+            <a:ext cx="1346200" cy="266700"/>
             <a:chOff x="0" y="0"/>
-            <a:chExt cx="1238250" cy="254000"/>
+            <a:chExt cx="1346200" cy="266700"/>
           </a:xfrm>
         </p:grpSpPr>
         <p:sp>
@@ -5126,7 +5126,7 @@
           <p:spPr>
             <a:xfrm>
               <a:off x="0" y="0"/>
-              <a:ext cx="1238250" cy="254000"/>
+              <a:ext cx="1346200" cy="266700"/>
             </a:xfrm>
             <a:prstGeom prst="roundRect">
               <a:avLst>
@@ -5151,8 +5151,8 @@
           </p:nvSpPr>
           <p:spPr>
             <a:xfrm>
-              <a:off x="104998" y="30919"/>
-              <a:ext cx="1262062" cy="178631"/>
+              <a:off x="114300" y="28804"/>
+              <a:ext cx="1397000" cy="193954"/>
             </a:xfrm>
             <a:prstGeom prst="rect">
               <a:avLst/>
@@ -5167,12 +5167,12 @@
             <a:p>
               <a:pPr algn="l">
                 <a:lnSpc>
-                  <a:spcPts val="1410"/>
+                  <a:spcPts val="1531"/>
                 </a:lnSpc>
                 <a:buNone/>
               </a:pPr>
               <a:r>
-                <a:rPr lang="en-US" sz="1000" dirty="0">
+                <a:rPr lang="en-US" sz="1100" dirty="0">
                   <a:solidFill>
                     <a:srgbClr val="FFFFFF"/>
                   </a:solidFill>
@@ -5182,7 +5182,7 @@
                 </a:rPr>
                 <a:t>Data infographic</a:t>
               </a:r>
-              <a:endParaRPr lang="en-US" sz="1000" dirty="0"/>
+              <a:endParaRPr lang="en-US" sz="1100" dirty="0"/>
             </a:p>
           </p:txBody>
         </p:sp>
@@ -5195,10 +5195,10 @@
         </p:nvGrpSpPr>
         <p:grpSpPr>
           <a:xfrm>
-            <a:off x="977900" y="5581650"/>
-            <a:ext cx="1473200" cy="254000"/>
+            <a:off x="977900" y="5568950"/>
+            <a:ext cx="1600200" cy="266700"/>
             <a:chOff x="0" y="0"/>
-            <a:chExt cx="1473200" cy="254000"/>
+            <a:chExt cx="1600200" cy="266700"/>
           </a:xfrm>
         </p:grpSpPr>
         <p:sp>
@@ -5210,7 +5210,7 @@
           <p:spPr>
             <a:xfrm>
               <a:off x="0" y="0"/>
-              <a:ext cx="1473200" cy="254000"/>
+              <a:ext cx="1600200" cy="266700"/>
             </a:xfrm>
             <a:prstGeom prst="roundRect">
               <a:avLst>
@@ -5235,8 +5235,8 @@
           </p:nvSpPr>
           <p:spPr>
             <a:xfrm>
-              <a:off x="107913" y="30919"/>
-              <a:ext cx="1555750" cy="153231"/>
+              <a:off x="114300" y="28804"/>
+              <a:ext cx="1714500" cy="168554"/>
             </a:xfrm>
             <a:prstGeom prst="rect">
               <a:avLst/>
@@ -5251,12 +5251,12 @@
             <a:p>
               <a:pPr algn="l">
                 <a:lnSpc>
-                  <a:spcPts val="1410"/>
+                  <a:spcPts val="1531"/>
                 </a:lnSpc>
                 <a:buNone/>
               </a:pPr>
               <a:r>
-                <a:rPr lang="en-US" sz="1000" dirty="0">
+                <a:rPr lang="en-US" sz="1100" dirty="0">
                   <a:solidFill>
                     <a:srgbClr val="FFFFFF"/>
                   </a:solidFill>
@@ -5266,7 +5266,7 @@
                 </a:rPr>
                 <a:t>Character animation</a:t>
               </a:r>
-              <a:endParaRPr lang="en-US" sz="1000" dirty="0"/>
+              <a:endParaRPr lang="en-US" sz="1100" dirty="0"/>
             </a:p>
           </p:txBody>
         </p:sp>
@@ -5279,10 +5279,10 @@
         </p:nvGrpSpPr>
         <p:grpSpPr>
           <a:xfrm>
-            <a:off x="3625850" y="5581650"/>
-            <a:ext cx="1035050" cy="254000"/>
+            <a:off x="3625850" y="5568950"/>
+            <a:ext cx="1123950" cy="266700"/>
             <a:chOff x="0" y="0"/>
-            <a:chExt cx="1035050" cy="254000"/>
+            <a:chExt cx="1123950" cy="266700"/>
           </a:xfrm>
         </p:grpSpPr>
         <p:sp>
@@ -5294,7 +5294,7 @@
           <p:spPr>
             <a:xfrm>
               <a:off x="0" y="0"/>
-              <a:ext cx="1035050" cy="254000"/>
+              <a:ext cx="1123950" cy="266700"/>
             </a:xfrm>
             <a:prstGeom prst="roundRect">
               <a:avLst>
@@ -5319,8 +5319,8 @@
           </p:nvSpPr>
           <p:spPr>
             <a:xfrm>
-              <a:off x="104998" y="30919"/>
-              <a:ext cx="1008062" cy="178631"/>
+              <a:off x="114300" y="28804"/>
+              <a:ext cx="1119188" cy="193954"/>
             </a:xfrm>
             <a:prstGeom prst="rect">
               <a:avLst/>
@@ -5335,12 +5335,12 @@
             <a:p>
               <a:pPr algn="l">
                 <a:lnSpc>
-                  <a:spcPts val="1410"/>
+                  <a:spcPts val="1531"/>
                 </a:lnSpc>
                 <a:buNone/>
               </a:pPr>
               <a:r>
-                <a:rPr lang="en-US" sz="1000" dirty="0">
+                <a:rPr lang="en-US" sz="1100" dirty="0">
                   <a:solidFill>
                     <a:srgbClr val="FFFFFF"/>
                   </a:solidFill>
@@ -5350,7 +5350,7 @@
                 </a:rPr>
                 <a:t>Photo editing</a:t>
               </a:r>
-              <a:endParaRPr lang="en-US" sz="1000" dirty="0"/>
+              <a:endParaRPr lang="en-US" sz="1100" dirty="0"/>
             </a:p>
           </p:txBody>
         </p:sp>
@@ -5363,10 +5363,10 @@
         </p:nvGrpSpPr>
         <p:grpSpPr>
           <a:xfrm>
-            <a:off x="6273800" y="5581650"/>
-            <a:ext cx="819150" cy="254000"/>
+            <a:off x="6273800" y="5568950"/>
+            <a:ext cx="882650" cy="266700"/>
             <a:chOff x="0" y="0"/>
-            <a:chExt cx="819150" cy="254000"/>
+            <a:chExt cx="882650" cy="266700"/>
           </a:xfrm>
         </p:grpSpPr>
         <p:sp>
@@ -5378,7 +5378,7 @@
           <p:spPr>
             <a:xfrm>
               <a:off x="0" y="0"/>
-              <a:ext cx="819150" cy="254000"/>
+              <a:ext cx="882650" cy="266700"/>
             </a:xfrm>
             <a:prstGeom prst="roundRect">
               <a:avLst>
@@ -5403,8 +5403,8 @@
           </p:nvSpPr>
           <p:spPr>
             <a:xfrm>
-              <a:off x="109153" y="30919"/>
-              <a:ext cx="781050" cy="178631"/>
+              <a:off x="114300" y="28804"/>
+              <a:ext cx="863600" cy="193954"/>
             </a:xfrm>
             <a:prstGeom prst="rect">
               <a:avLst/>
@@ -5419,12 +5419,12 @@
             <a:p>
               <a:pPr algn="l">
                 <a:lnSpc>
-                  <a:spcPts val="1410"/>
+                  <a:spcPts val="1531"/>
                 </a:lnSpc>
                 <a:buNone/>
               </a:pPr>
               <a:r>
-                <a:rPr lang="en-US" sz="1000" dirty="0">
+                <a:rPr lang="en-US" sz="1100" dirty="0">
                   <a:solidFill>
                     <a:srgbClr val="FFFFFF"/>
                   </a:solidFill>
@@ -5434,7 +5434,7 @@
                 </a:rPr>
                 <a:t>Tile maps</a:t>
               </a:r>
-              <a:endParaRPr lang="en-US" sz="1000" dirty="0"/>
+              <a:endParaRPr lang="en-US" sz="1100" dirty="0"/>
             </a:p>
           </p:txBody>
         </p:sp>
@@ -5447,10 +5447,10 @@
         </p:nvGrpSpPr>
         <p:grpSpPr>
           <a:xfrm>
-            <a:off x="8921750" y="5581650"/>
-            <a:ext cx="1143000" cy="254000"/>
+            <a:off x="8921750" y="5568950"/>
+            <a:ext cx="1244600" cy="266700"/>
             <a:chOff x="0" y="0"/>
-            <a:chExt cx="1143000" cy="254000"/>
+            <a:chExt cx="1244600" cy="266700"/>
           </a:xfrm>
         </p:grpSpPr>
         <p:sp>
@@ -5462,7 +5462,7 @@
           <p:spPr>
             <a:xfrm>
               <a:off x="0" y="0"/>
-              <a:ext cx="1143000" cy="254000"/>
+              <a:ext cx="1244600" cy="266700"/>
             </a:xfrm>
             <a:prstGeom prst="roundRect">
               <a:avLst>
@@ -5487,8 +5487,8 @@
           </p:nvSpPr>
           <p:spPr>
             <a:xfrm>
-              <a:off x="104998" y="30919"/>
-              <a:ext cx="1143000" cy="153231"/>
+              <a:off x="114300" y="28804"/>
+              <a:ext cx="1270000" cy="168554"/>
             </a:xfrm>
             <a:prstGeom prst="rect">
               <a:avLst/>
@@ -5503,12 +5503,12 @@
             <a:p>
               <a:pPr algn="l">
                 <a:lnSpc>
-                  <a:spcPts val="1410"/>
+                  <a:spcPts val="1531"/>
                 </a:lnSpc>
                 <a:buNone/>
               </a:pPr>
               <a:r>
-                <a:rPr lang="en-US" sz="1000" dirty="0">
+                <a:rPr lang="en-US" sz="1100" dirty="0">
                   <a:solidFill>
                     <a:srgbClr val="FFFFFF"/>
                   </a:solidFill>
@@ -5518,7 +5518,7 @@
                 </a:rPr>
                 <a:t>Editable charts</a:t>
               </a:r>
-              <a:endParaRPr lang="en-US" sz="1000" dirty="0"/>
+              <a:endParaRPr lang="en-US" sz="1100" dirty="0"/>
             </a:p>
           </p:txBody>
         </p:sp>
@@ -5615,8 +5615,8 @@
         </p:nvSpPr>
         <p:spPr>
           <a:xfrm>
-            <a:off x="11103204" y="6178804"/>
-            <a:ext cx="311150" cy="183896"/>
+            <a:off x="11112500" y="6178804"/>
+            <a:ext cx="323850" cy="183896"/>
           </a:xfrm>
           <a:prstGeom prst="rect">
             <a:avLst/>
@@ -5658,8 +5658,8 @@
         </p:nvSpPr>
         <p:spPr>
           <a:xfrm>
-            <a:off x="874471" y="563537"/>
-            <a:ext cx="2587625" cy="198463"/>
+            <a:off x="889000" y="563537"/>
+            <a:ext cx="2603500" cy="198463"/>
           </a:xfrm>
           <a:prstGeom prst="rect">
             <a:avLst/>
@@ -5766,11 +5766,11 @@
         <p:spPr>
           <a:xfrm>
             <a:off x="889000" y="2203450"/>
-            <a:ext cx="3302000" cy="2349500"/>
+            <a:ext cx="3302000" cy="2667000"/>
           </a:xfrm>
           <a:prstGeom prst="roundRect">
             <a:avLst>
-              <a:gd name="adj" fmla="val 6486"/>
+              <a:gd name="adj" fmla="val 5714"/>
             </a:avLst>
           </a:prstGeom>
           <a:solidFill>
@@ -5789,8 +5789,8 @@
         </p:nvSpPr>
         <p:spPr>
           <a:xfrm>
-            <a:off x="1159942" y="2441389"/>
-            <a:ext cx="1447800" cy="301811"/>
+            <a:off x="1168400" y="2441389"/>
+            <a:ext cx="1460500" cy="301811"/>
           </a:xfrm>
           <a:prstGeom prst="rect">
             <a:avLst/>
@@ -5833,7 +5833,7 @@
         <p:spPr>
           <a:xfrm>
             <a:off x="1143000" y="2616200"/>
-            <a:ext cx="1079500" cy="25400"/>
+            <a:ext cx="1092200" cy="25400"/>
           </a:xfrm>
           <a:prstGeom prst="rect">
             <a:avLst/>
@@ -5854,8 +5854,8 @@
         </p:nvSpPr>
         <p:spPr>
           <a:xfrm>
-            <a:off x="1143409" y="2740930"/>
-            <a:ext cx="2628900" cy="834120"/>
+            <a:off x="1168400" y="2740930"/>
+            <a:ext cx="2654300" cy="834120"/>
           </a:xfrm>
           <a:prstGeom prst="rect">
             <a:avLst/>
@@ -5947,11 +5947,11 @@
         <p:spPr>
           <a:xfrm>
             <a:off x="4445000" y="2203450"/>
-            <a:ext cx="3302000" cy="2349500"/>
+            <a:ext cx="3302000" cy="2667000"/>
           </a:xfrm>
           <a:prstGeom prst="roundRect">
             <a:avLst>
-              <a:gd name="adj" fmla="val 6486"/>
+              <a:gd name="adj" fmla="val 5714"/>
             </a:avLst>
           </a:prstGeom>
           <a:solidFill>
@@ -5970,8 +5970,8 @@
         </p:nvSpPr>
         <p:spPr>
           <a:xfrm>
-            <a:off x="4715123" y="2431295"/>
-            <a:ext cx="1054100" cy="305555"/>
+            <a:off x="4724400" y="2431295"/>
+            <a:ext cx="1066800" cy="305555"/>
           </a:xfrm>
           <a:prstGeom prst="rect">
             <a:avLst/>
@@ -6014,7 +6014,7 @@
         <p:spPr>
           <a:xfrm>
             <a:off x="4699000" y="2616200"/>
-            <a:ext cx="685800" cy="25400"/>
+            <a:ext cx="698500" cy="25400"/>
           </a:xfrm>
           <a:prstGeom prst="rect">
             <a:avLst/>
@@ -6035,8 +6035,8 @@
         </p:nvSpPr>
         <p:spPr>
           <a:xfrm>
-            <a:off x="4699409" y="2748992"/>
-            <a:ext cx="2946400" cy="838758"/>
+            <a:off x="4724400" y="2748992"/>
+            <a:ext cx="2971800" cy="838758"/>
           </a:xfrm>
           <a:prstGeom prst="rect">
             <a:avLst/>
@@ -6128,11 +6128,11 @@
         <p:spPr>
           <a:xfrm>
             <a:off x="8001000" y="2203450"/>
-            <a:ext cx="3302000" cy="2349500"/>
+            <a:ext cx="3302000" cy="2667000"/>
           </a:xfrm>
           <a:prstGeom prst="roundRect">
             <a:avLst>
-              <a:gd name="adj" fmla="val 6486"/>
+              <a:gd name="adj" fmla="val 5714"/>
             </a:avLst>
           </a:prstGeom>
           <a:solidFill>
@@ -6151,8 +6151,8 @@
         </p:nvSpPr>
         <p:spPr>
           <a:xfrm>
-            <a:off x="8271942" y="2430884"/>
-            <a:ext cx="1155700" cy="299616"/>
+            <a:off x="8280400" y="2430884"/>
+            <a:ext cx="1162050" cy="299616"/>
           </a:xfrm>
           <a:prstGeom prst="rect">
             <a:avLst/>
@@ -6195,7 +6195,7 @@
         <p:spPr>
           <a:xfrm>
             <a:off x="8255000" y="2616200"/>
-            <a:ext cx="787400" cy="25400"/>
+            <a:ext cx="793750" cy="25400"/>
           </a:xfrm>
           <a:prstGeom prst="rect">
             <a:avLst/>
@@ -6216,8 +6216,8 @@
         </p:nvSpPr>
         <p:spPr>
           <a:xfrm>
-            <a:off x="8252991" y="2748992"/>
-            <a:ext cx="3136900" cy="838758"/>
+            <a:off x="8280400" y="2748992"/>
+            <a:ext cx="3162300" cy="838758"/>
           </a:xfrm>
           <a:prstGeom prst="rect">
             <a:avLst/>
@@ -6308,7 +6308,7 @@
         </p:nvSpPr>
         <p:spPr>
           <a:xfrm>
-            <a:off x="889000" y="4876280"/>
+            <a:off x="889000" y="5066780"/>
             <a:ext cx="10414000" cy="648220"/>
           </a:xfrm>
           <a:prstGeom prst="rect">
@@ -6343,7 +6343,7 @@
                 <a:ea typeface="Inter"/>
                 <a:cs typeface="Inter"/>
               </a:rPr>
-              <a:t>Timings from the repository's exploration projects (explorations/README.md), before and after the recent performance work.</a:t>
+              <a:t>Timings from the repository's exploration projects (explorations/README.md), before and after the performance fixes in Vixl 0.18.0.</a:t>
             </a:r>
             <a:endParaRPr lang="en-US" sz="1400" dirty="0"/>
           </a:p>
@@ -6441,8 +6441,8 @@
         </p:nvSpPr>
         <p:spPr>
           <a:xfrm>
-            <a:off x="11101832" y="6178804"/>
-            <a:ext cx="311150" cy="183896"/>
+            <a:off x="11112500" y="6178804"/>
+            <a:ext cx="323850" cy="183896"/>
           </a:xfrm>
           <a:prstGeom prst="rect">
             <a:avLst/>
@@ -6484,8 +6484,8 @@
         </p:nvSpPr>
         <p:spPr>
           <a:xfrm>
-            <a:off x="872820" y="563537"/>
-            <a:ext cx="1225550" cy="198463"/>
+            <a:off x="889000" y="563537"/>
+            <a:ext cx="1238250" cy="198463"/>
           </a:xfrm>
           <a:prstGeom prst="rect">
             <a:avLst/>
@@ -6615,8 +6615,8 @@
         </p:nvSpPr>
         <p:spPr>
           <a:xfrm>
-            <a:off x="1126331" y="2337991"/>
-            <a:ext cx="1511300" cy="424259"/>
+            <a:off x="1143000" y="2337991"/>
+            <a:ext cx="1530350" cy="424259"/>
           </a:xfrm>
           <a:prstGeom prst="rect">
             <a:avLst/>
@@ -6780,8 +6780,8 @@
         </p:nvSpPr>
         <p:spPr>
           <a:xfrm>
-            <a:off x="3783806" y="2337991"/>
-            <a:ext cx="1219200" cy="424259"/>
+            <a:off x="3797300" y="2337991"/>
+            <a:ext cx="1231900" cy="424259"/>
           </a:xfrm>
           <a:prstGeom prst="rect">
             <a:avLst/>
@@ -6945,8 +6945,8 @@
         </p:nvSpPr>
         <p:spPr>
           <a:xfrm>
-            <a:off x="6428581" y="2334022"/>
-            <a:ext cx="1968500" cy="504428"/>
+            <a:off x="6445250" y="2334022"/>
+            <a:ext cx="1987550" cy="504428"/>
           </a:xfrm>
           <a:prstGeom prst="rect">
             <a:avLst/>
@@ -7110,8 +7110,8 @@
         </p:nvSpPr>
         <p:spPr>
           <a:xfrm>
-            <a:off x="9076531" y="2337991"/>
-            <a:ext cx="1612900" cy="424259"/>
+            <a:off x="9093200" y="2337991"/>
+            <a:ext cx="1631950" cy="424259"/>
           </a:xfrm>
           <a:prstGeom prst="rect">
             <a:avLst/>
@@ -7335,8 +7335,8 @@
         </p:nvSpPr>
         <p:spPr>
           <a:xfrm>
-            <a:off x="11101527" y="6180480"/>
-            <a:ext cx="311150" cy="188570"/>
+            <a:off x="11112500" y="6180480"/>
+            <a:ext cx="323850" cy="188570"/>
           </a:xfrm>
           <a:prstGeom prst="rect">
             <a:avLst/>
@@ -7378,8 +7378,8 @@
         </p:nvSpPr>
         <p:spPr>
           <a:xfrm>
-            <a:off x="875792" y="563537"/>
-            <a:ext cx="933450" cy="198463"/>
+            <a:off x="889000" y="563537"/>
+            <a:ext cx="946150" cy="198463"/>
           </a:xfrm>
           <a:prstGeom prst="rect">
             <a:avLst/>
@@ -7509,8 +7509,8 @@
         </p:nvSpPr>
         <p:spPr>
           <a:xfrm>
-            <a:off x="1107182" y="2347863"/>
-            <a:ext cx="895350" cy="274687"/>
+            <a:off x="1117600" y="2347863"/>
+            <a:ext cx="908050" cy="274687"/>
           </a:xfrm>
           <a:prstGeom prst="rect">
             <a:avLst/>
@@ -7576,8 +7576,8 @@
         </p:nvSpPr>
         <p:spPr>
           <a:xfrm>
-            <a:off x="3764682" y="2347863"/>
-            <a:ext cx="1016000" cy="274687"/>
+            <a:off x="3765550" y="2347863"/>
+            <a:ext cx="1022350" cy="274687"/>
           </a:xfrm>
           <a:prstGeom prst="rect">
             <a:avLst/>
@@ -7643,7 +7643,7 @@
         </p:nvSpPr>
         <p:spPr>
           <a:xfrm>
-            <a:off x="6412880" y="2345382"/>
+            <a:off x="6413500" y="2345382"/>
             <a:ext cx="1117600" cy="277168"/>
           </a:xfrm>
           <a:prstGeom prst="rect">
@@ -7710,7 +7710,7 @@
         </p:nvSpPr>
         <p:spPr>
           <a:xfrm>
-            <a:off x="9056985" y="2345382"/>
+            <a:off x="9061450" y="2345382"/>
             <a:ext cx="895350" cy="277168"/>
           </a:xfrm>
           <a:prstGeom prst="rect">
@@ -7777,8 +7777,8 @@
         </p:nvSpPr>
         <p:spPr>
           <a:xfrm>
-            <a:off x="1115368" y="3259782"/>
-            <a:ext cx="939800" cy="277168"/>
+            <a:off x="1117600" y="3259782"/>
+            <a:ext cx="946150" cy="277168"/>
           </a:xfrm>
           <a:prstGeom prst="rect">
             <a:avLst/>
@@ -7844,7 +7844,7 @@
         </p:nvSpPr>
         <p:spPr>
           <a:xfrm>
-            <a:off x="3760465" y="3262263"/>
+            <a:off x="3765550" y="3262263"/>
             <a:ext cx="908050" cy="274687"/>
           </a:xfrm>
           <a:prstGeom prst="rect">
@@ -7911,8 +7911,8 @@
         </p:nvSpPr>
         <p:spPr>
           <a:xfrm>
-            <a:off x="6403082" y="3259782"/>
-            <a:ext cx="850900" cy="277168"/>
+            <a:off x="6413500" y="3259782"/>
+            <a:ext cx="863600" cy="277168"/>
           </a:xfrm>
           <a:prstGeom prst="rect">
             <a:avLst/>
@@ -7978,8 +7978,8 @@
         </p:nvSpPr>
         <p:spPr>
           <a:xfrm>
-            <a:off x="9051032" y="3259782"/>
-            <a:ext cx="1035050" cy="277168"/>
+            <a:off x="9061450" y="3259782"/>
+            <a:ext cx="1047750" cy="277168"/>
           </a:xfrm>
           <a:prstGeom prst="rect">
             <a:avLst/>
@@ -8045,8 +8045,8 @@
         </p:nvSpPr>
         <p:spPr>
           <a:xfrm>
-            <a:off x="1107182" y="4174182"/>
-            <a:ext cx="1085850" cy="277168"/>
+            <a:off x="1117600" y="4174182"/>
+            <a:ext cx="1098550" cy="277168"/>
           </a:xfrm>
           <a:prstGeom prst="rect">
             <a:avLst/>
@@ -8112,8 +8112,8 @@
         </p:nvSpPr>
         <p:spPr>
           <a:xfrm>
-            <a:off x="3755132" y="4176663"/>
-            <a:ext cx="819150" cy="274687"/>
+            <a:off x="3765550" y="4176663"/>
+            <a:ext cx="825500" cy="274687"/>
           </a:xfrm>
           <a:prstGeom prst="rect">
             <a:avLst/>
@@ -8179,8 +8179,8 @@
         </p:nvSpPr>
         <p:spPr>
           <a:xfrm>
-            <a:off x="6405066" y="4176663"/>
-            <a:ext cx="768350" cy="274687"/>
+            <a:off x="6413500" y="4176663"/>
+            <a:ext cx="781050" cy="274687"/>
           </a:xfrm>
           <a:prstGeom prst="rect">
             <a:avLst/>
@@ -8246,8 +8246,8 @@
         </p:nvSpPr>
         <p:spPr>
           <a:xfrm>
-            <a:off x="9051032" y="4174182"/>
-            <a:ext cx="927100" cy="277168"/>
+            <a:off x="9061450" y="4174182"/>
+            <a:ext cx="939800" cy="277168"/>
           </a:xfrm>
           <a:prstGeom prst="rect">
             <a:avLst/>
@@ -8313,8 +8313,8 @@
         </p:nvSpPr>
         <p:spPr>
           <a:xfrm>
-            <a:off x="1109166" y="5091063"/>
-            <a:ext cx="1143000" cy="274687"/>
+            <a:off x="1117600" y="5091063"/>
+            <a:ext cx="1149350" cy="274687"/>
           </a:xfrm>
           <a:prstGeom prst="rect">
             <a:avLst/>
@@ -8380,7 +8380,7 @@
         </p:nvSpPr>
         <p:spPr>
           <a:xfrm>
-            <a:off x="3764930" y="5088582"/>
+            <a:off x="3765550" y="5088582"/>
             <a:ext cx="1162050" cy="277168"/>
           </a:xfrm>
           <a:prstGeom prst="rect">
@@ -8447,8 +8447,8 @@
         </p:nvSpPr>
         <p:spPr>
           <a:xfrm>
-            <a:off x="6411268" y="5091063"/>
-            <a:ext cx="1092200" cy="274687"/>
+            <a:off x="6413500" y="5091063"/>
+            <a:ext cx="1098550" cy="274687"/>
           </a:xfrm>
           <a:prstGeom prst="rect">
             <a:avLst/>
@@ -8514,8 +8514,8 @@
         </p:nvSpPr>
         <p:spPr>
           <a:xfrm>
-            <a:off x="9056365" y="5100613"/>
-            <a:ext cx="1976438" cy="328637"/>
+            <a:off x="9061450" y="5100613"/>
+            <a:ext cx="1695450" cy="277837"/>
           </a:xfrm>
           <a:prstGeom prst="rect">
             <a:avLst/>
@@ -8543,7 +8543,7 @@
                 <a:ea typeface="Inter Tight"/>
                 <a:cs typeface="Inter Tight"/>
               </a:rPr>
-              <a:t>Sprite sheets</a:t>
+              <a:t>WAV audio</a:t>
             </a:r>
             <a:endParaRPr lang="en-US" sz="2000" dirty="0"/>
           </a:p>
@@ -8843,8 +8843,8 @@
           </p:nvSpPr>
           <p:spPr>
             <a:xfrm>
-              <a:off x="627532" y="52629"/>
-              <a:ext cx="958850" cy="188671"/>
+              <a:off x="635000" y="52629"/>
+              <a:ext cx="965200" cy="188671"/>
             </a:xfrm>
             <a:prstGeom prst="rect">
               <a:avLst/>
@@ -9008,8 +9008,8 @@
         </p:nvSpPr>
         <p:spPr>
           <a:xfrm>
-            <a:off x="3154680" y="5768340"/>
-            <a:ext cx="4548188" cy="334010"/>
+            <a:off x="3175000" y="5768340"/>
+            <a:ext cx="4572000" cy="334010"/>
           </a:xfrm>
           <a:prstGeom prst="rect">
             <a:avLst/>

</xml_diff>

<commit_message>
Rebuild the marketing kit with the 0.21 renderer
Co-Authored-By: Claude Sonnet 5.5 <noreply@anthropic.com>
Claude-Session: https://claude.ai/code/session_011Mu8TrA4uLjwSH9YN5Lkj6
</commit_message>
<xml_diff>
--- a/marketing/output/deck/vixl-pitch-deck.pptx
+++ b/marketing/output/deck/vixl-pitch-deck.pptx
@@ -1387,7 +1387,7 @@
               <a:buNone/>
             </a:pPr>
             <a:r>
-              <a:rPr lang="en-US" sz="1600" dirty="0">
+              <a:rPr lang="en-US" sz="1600" b="1" dirty="0">
                 <a:solidFill>
                   <a:srgbClr val="6A9AFF"/>
                 </a:solidFill>
@@ -1430,7 +1430,7 @@
               <a:buNone/>
             </a:pPr>
             <a:r>
-              <a:rPr lang="en-US" sz="2600" dirty="0">
+              <a:rPr lang="en-US" sz="2600" b="1" dirty="0">
                 <a:solidFill>
                   <a:srgbClr val="FFFFFF"/>
                 </a:solidFill>
@@ -1546,7 +1546,7 @@
               <a:buNone/>
             </a:pPr>
             <a:r>
-              <a:rPr lang="en-US" sz="1600" dirty="0">
+              <a:rPr lang="en-US" sz="1600" b="1" dirty="0">
                 <a:solidFill>
                   <a:srgbClr val="6A9AFF"/>
                 </a:solidFill>
@@ -1589,7 +1589,7 @@
               <a:buNone/>
             </a:pPr>
             <a:r>
-              <a:rPr lang="en-US" sz="2600" dirty="0">
+              <a:rPr lang="en-US" sz="2600" b="1" dirty="0">
                 <a:solidFill>
                   <a:srgbClr val="FFFFFF"/>
                 </a:solidFill>
@@ -1705,7 +1705,7 @@
               <a:buNone/>
             </a:pPr>
             <a:r>
-              <a:rPr lang="en-US" sz="1600" dirty="0">
+              <a:rPr lang="en-US" sz="1600" b="1" dirty="0">
                 <a:solidFill>
                   <a:srgbClr val="6A9AFF"/>
                 </a:solidFill>
@@ -1748,7 +1748,7 @@
               <a:buNone/>
             </a:pPr>
             <a:r>
-              <a:rPr lang="en-US" sz="2600" dirty="0">
+              <a:rPr lang="en-US" sz="2600" b="1" dirty="0">
                 <a:solidFill>
                   <a:srgbClr val="FFFFFF"/>
                 </a:solidFill>
@@ -3234,7 +3234,7 @@
               <a:buNone/>
             </a:pPr>
             <a:r>
-              <a:rPr lang="en-US" sz="1550" dirty="0">
+              <a:rPr lang="en-US" sz="1550" b="1" dirty="0">
                 <a:solidFill>
                   <a:srgbClr val="6A9AFF"/>
                 </a:solidFill>
@@ -3277,7 +3277,7 @@
               <a:buNone/>
             </a:pPr>
             <a:r>
-              <a:rPr lang="en-US" sz="2200" dirty="0">
+              <a:rPr lang="en-US" sz="2200" b="1" dirty="0">
                 <a:solidFill>
                   <a:srgbClr val="FFFFFF"/>
                 </a:solidFill>
@@ -3445,7 +3445,7 @@
               <a:buNone/>
             </a:pPr>
             <a:r>
-              <a:rPr lang="en-US" sz="1550" dirty="0">
+              <a:rPr lang="en-US" sz="1550" b="1" dirty="0">
                 <a:solidFill>
                   <a:srgbClr val="6A9AFF"/>
                 </a:solidFill>
@@ -3488,7 +3488,7 @@
               <a:buNone/>
             </a:pPr>
             <a:r>
-              <a:rPr lang="en-US" sz="2200" dirty="0">
+              <a:rPr lang="en-US" sz="2200" b="1" dirty="0">
                 <a:solidFill>
                   <a:srgbClr val="FFFFFF"/>
                 </a:solidFill>
@@ -3656,7 +3656,7 @@
               <a:buNone/>
             </a:pPr>
             <a:r>
-              <a:rPr lang="en-US" sz="1550" dirty="0">
+              <a:rPr lang="en-US" sz="1550" b="1" dirty="0">
                 <a:solidFill>
                   <a:srgbClr val="6A9AFF"/>
                 </a:solidFill>
@@ -3699,7 +3699,7 @@
               <a:buNone/>
             </a:pPr>
             <a:r>
-              <a:rPr lang="en-US" sz="2200" dirty="0">
+              <a:rPr lang="en-US" sz="2200" b="1" dirty="0">
                 <a:solidFill>
                   <a:srgbClr val="FFFFFF"/>
                 </a:solidFill>
@@ -3867,7 +3867,7 @@
               <a:buNone/>
             </a:pPr>
             <a:r>
-              <a:rPr lang="en-US" sz="1550" dirty="0">
+              <a:rPr lang="en-US" sz="1550" b="1" dirty="0">
                 <a:solidFill>
                   <a:srgbClr val="6A9AFF"/>
                 </a:solidFill>
@@ -3910,7 +3910,7 @@
               <a:buNone/>
             </a:pPr>
             <a:r>
-              <a:rPr lang="en-US" sz="2200" dirty="0">
+              <a:rPr lang="en-US" sz="2200" b="1" dirty="0">
                 <a:solidFill>
                   <a:srgbClr val="FFFFFF"/>
                 </a:solidFill>
@@ -4078,7 +4078,7 @@
               <a:buNone/>
             </a:pPr>
             <a:r>
-              <a:rPr lang="en-US" sz="1550" dirty="0">
+              <a:rPr lang="en-US" sz="1550" b="1" dirty="0">
                 <a:solidFill>
                   <a:srgbClr val="6A9AFF"/>
                 </a:solidFill>
@@ -4121,7 +4121,7 @@
               <a:buNone/>
             </a:pPr>
             <a:r>
-              <a:rPr lang="en-US" sz="2200" dirty="0">
+              <a:rPr lang="en-US" sz="2200" b="1" dirty="0">
                 <a:solidFill>
                   <a:srgbClr val="FFFFFF"/>
                 </a:solidFill>
@@ -4920,7 +4920,7 @@
                 <a:buNone/>
               </a:pPr>
               <a:r>
-                <a:rPr lang="en-US" sz="1100" dirty="0">
+                <a:rPr lang="en-US" sz="1100" b="1" dirty="0">
                   <a:solidFill>
                     <a:srgbClr val="FFFFFF"/>
                   </a:solidFill>
@@ -5004,7 +5004,7 @@
                 <a:buNone/>
               </a:pPr>
               <a:r>
-                <a:rPr lang="en-US" sz="1100" dirty="0">
+                <a:rPr lang="en-US" sz="1100" b="1" dirty="0">
                   <a:solidFill>
                     <a:srgbClr val="FFFFFF"/>
                   </a:solidFill>
@@ -5088,7 +5088,7 @@
                 <a:buNone/>
               </a:pPr>
               <a:r>
-                <a:rPr lang="en-US" sz="1100" dirty="0">
+                <a:rPr lang="en-US" sz="1100" b="1" dirty="0">
                   <a:solidFill>
                     <a:srgbClr val="FFFFFF"/>
                   </a:solidFill>
@@ -5172,7 +5172,7 @@
                 <a:buNone/>
               </a:pPr>
               <a:r>
-                <a:rPr lang="en-US" sz="1100" dirty="0">
+                <a:rPr lang="en-US" sz="1100" b="1" dirty="0">
                   <a:solidFill>
                     <a:srgbClr val="FFFFFF"/>
                   </a:solidFill>
@@ -5256,7 +5256,7 @@
                 <a:buNone/>
               </a:pPr>
               <a:r>
-                <a:rPr lang="en-US" sz="1100" dirty="0">
+                <a:rPr lang="en-US" sz="1100" b="1" dirty="0">
                   <a:solidFill>
                     <a:srgbClr val="FFFFFF"/>
                   </a:solidFill>
@@ -5340,7 +5340,7 @@
                 <a:buNone/>
               </a:pPr>
               <a:r>
-                <a:rPr lang="en-US" sz="1100" dirty="0">
+                <a:rPr lang="en-US" sz="1100" b="1" dirty="0">
                   <a:solidFill>
                     <a:srgbClr val="FFFFFF"/>
                   </a:solidFill>
@@ -5424,7 +5424,7 @@
                 <a:buNone/>
               </a:pPr>
               <a:r>
-                <a:rPr lang="en-US" sz="1100" dirty="0">
+                <a:rPr lang="en-US" sz="1100" b="1" dirty="0">
                   <a:solidFill>
                     <a:srgbClr val="FFFFFF"/>
                   </a:solidFill>
@@ -5508,7 +5508,7 @@
                 <a:buNone/>
               </a:pPr>
               <a:r>
-                <a:rPr lang="en-US" sz="1100" dirty="0">
+                <a:rPr lang="en-US" sz="1100" b="1" dirty="0">
                   <a:solidFill>
                     <a:srgbClr val="FFFFFF"/>
                   </a:solidFill>
@@ -5696,12 +5696,8 @@
       <p:sp>
         <p:nvSpPr>
           <p:cNvPr id="6" name="qa-title"/>
-          <p:cNvSpPr>
-            <a:spLocks noGrp="1"/>
-          </p:cNvSpPr>
-          <p:nvPr>
-            <p:ph type="title"/>
-          </p:nvPr>
+          <p:cNvSpPr txBox="1"/>
+          <p:nvPr/>
         </p:nvSpPr>
         <p:spPr>
           <a:xfrm>
@@ -5810,7 +5806,7 @@
               <a:buNone/>
             </a:pPr>
             <a:r>
-              <a:rPr lang="en-US" sz="2200" dirty="0">
+              <a:rPr lang="en-US" sz="2200" b="1" dirty="0">
                 <a:solidFill>
                   <a:srgbClr val="AEB7CA"/>
                 </a:solidFill>
@@ -5875,7 +5871,7 @@
               <a:buNone/>
             </a:pPr>
             <a:r>
-              <a:rPr lang="en-US" sz="6500" dirty="0">
+              <a:rPr lang="en-US" sz="6500" b="1" dirty="0">
                 <a:solidFill>
                   <a:srgbClr val="6A9AFF"/>
                 </a:solidFill>
@@ -5991,7 +5987,7 @@
               <a:buNone/>
             </a:pPr>
             <a:r>
-              <a:rPr lang="en-US" sz="2200" dirty="0">
+              <a:rPr lang="en-US" sz="2200" b="1" dirty="0">
                 <a:solidFill>
                   <a:srgbClr val="AEB7CA"/>
                 </a:solidFill>
@@ -6056,7 +6052,7 @@
               <a:buNone/>
             </a:pPr>
             <a:r>
-              <a:rPr lang="en-US" sz="6500" dirty="0">
+              <a:rPr lang="en-US" sz="6500" b="1" dirty="0">
                 <a:solidFill>
                   <a:srgbClr val="6A9AFF"/>
                 </a:solidFill>
@@ -6172,7 +6168,7 @@
               <a:buNone/>
             </a:pPr>
             <a:r>
-              <a:rPr lang="en-US" sz="2200" dirty="0">
+              <a:rPr lang="en-US" sz="2200" b="1" dirty="0">
                 <a:solidFill>
                   <a:srgbClr val="AEB7CA"/>
                 </a:solidFill>
@@ -6237,7 +6233,7 @@
               <a:buNone/>
             </a:pPr>
             <a:r>
-              <a:rPr lang="en-US" sz="6500" dirty="0">
+              <a:rPr lang="en-US" sz="6500" b="1" dirty="0">
                 <a:solidFill>
                   <a:srgbClr val="6A9AFF"/>
                 </a:solidFill>
@@ -6636,7 +6632,7 @@
               <a:buNone/>
             </a:pPr>
             <a:r>
-              <a:rPr lang="en-US" sz="3200" dirty="0">
+              <a:rPr lang="en-US" sz="3200" b="1" dirty="0">
                 <a:solidFill>
                   <a:srgbClr val="6A9AFF"/>
                 </a:solidFill>
@@ -6801,7 +6797,7 @@
               <a:buNone/>
             </a:pPr>
             <a:r>
-              <a:rPr lang="en-US" sz="3200" dirty="0">
+              <a:rPr lang="en-US" sz="3200" b="1" dirty="0">
                 <a:solidFill>
                   <a:srgbClr val="FFFFFF"/>
                 </a:solidFill>
@@ -6966,7 +6962,7 @@
               <a:buNone/>
             </a:pPr>
             <a:r>
-              <a:rPr lang="en-US" sz="3200" dirty="0">
+              <a:rPr lang="en-US" sz="3200" b="1" dirty="0">
                 <a:solidFill>
                   <a:srgbClr val="FFFFFF"/>
                 </a:solidFill>
@@ -7131,7 +7127,7 @@
               <a:buNone/>
             </a:pPr>
             <a:r>
-              <a:rPr lang="en-US" sz="3200" dirty="0">
+              <a:rPr lang="en-US" sz="3200" b="1" dirty="0">
                 <a:solidFill>
                   <a:srgbClr val="FFFFFF"/>
                 </a:solidFill>
@@ -7530,7 +7526,7 @@
               <a:buNone/>
             </a:pPr>
             <a:r>
-              <a:rPr lang="en-US" sz="2000" dirty="0">
+              <a:rPr lang="en-US" sz="2000" b="1" dirty="0">
                 <a:solidFill>
                   <a:srgbClr val="FFFFFF"/>
                 </a:solidFill>
@@ -7597,7 +7593,7 @@
               <a:buNone/>
             </a:pPr>
             <a:r>
-              <a:rPr lang="en-US" sz="2000" dirty="0">
+              <a:rPr lang="en-US" sz="2000" b="1" dirty="0">
                 <a:solidFill>
                   <a:srgbClr val="FFFFFF"/>
                 </a:solidFill>
@@ -7664,7 +7660,7 @@
               <a:buNone/>
             </a:pPr>
             <a:r>
-              <a:rPr lang="en-US" sz="2000" dirty="0">
+              <a:rPr lang="en-US" sz="2000" b="1" dirty="0">
                 <a:solidFill>
                   <a:srgbClr val="FFFFFF"/>
                 </a:solidFill>
@@ -7731,7 +7727,7 @@
               <a:buNone/>
             </a:pPr>
             <a:r>
-              <a:rPr lang="en-US" sz="2000" dirty="0">
+              <a:rPr lang="en-US" sz="2000" b="1" dirty="0">
                 <a:solidFill>
                   <a:srgbClr val="FFFFFF"/>
                 </a:solidFill>
@@ -7798,7 +7794,7 @@
               <a:buNone/>
             </a:pPr>
             <a:r>
-              <a:rPr lang="en-US" sz="2000" dirty="0">
+              <a:rPr lang="en-US" sz="2000" b="1" dirty="0">
                 <a:solidFill>
                   <a:srgbClr val="FFFFFF"/>
                 </a:solidFill>
@@ -7865,7 +7861,7 @@
               <a:buNone/>
             </a:pPr>
             <a:r>
-              <a:rPr lang="en-US" sz="2000" dirty="0">
+              <a:rPr lang="en-US" sz="2000" b="1" dirty="0">
                 <a:solidFill>
                   <a:srgbClr val="FFFFFF"/>
                 </a:solidFill>
@@ -7932,7 +7928,7 @@
               <a:buNone/>
             </a:pPr>
             <a:r>
-              <a:rPr lang="en-US" sz="2000" dirty="0">
+              <a:rPr lang="en-US" sz="2000" b="1" dirty="0">
                 <a:solidFill>
                   <a:srgbClr val="FFFFFF"/>
                 </a:solidFill>
@@ -7999,7 +7995,7 @@
               <a:buNone/>
             </a:pPr>
             <a:r>
-              <a:rPr lang="en-US" sz="2000" dirty="0">
+              <a:rPr lang="en-US" sz="2000" b="1" dirty="0">
                 <a:solidFill>
                   <a:srgbClr val="FFFFFF"/>
                 </a:solidFill>
@@ -8066,7 +8062,7 @@
               <a:buNone/>
             </a:pPr>
             <a:r>
-              <a:rPr lang="en-US" sz="2000" dirty="0">
+              <a:rPr lang="en-US" sz="2000" b="1" dirty="0">
                 <a:solidFill>
                   <a:srgbClr val="FFFFFF"/>
                 </a:solidFill>
@@ -8133,7 +8129,7 @@
               <a:buNone/>
             </a:pPr>
             <a:r>
-              <a:rPr lang="en-US" sz="2000" dirty="0">
+              <a:rPr lang="en-US" sz="2000" b="1" dirty="0">
                 <a:solidFill>
                   <a:srgbClr val="FFFFFF"/>
                 </a:solidFill>
@@ -8200,7 +8196,7 @@
               <a:buNone/>
             </a:pPr>
             <a:r>
-              <a:rPr lang="en-US" sz="2000" dirty="0">
+              <a:rPr lang="en-US" sz="2000" b="1" dirty="0">
                 <a:solidFill>
                   <a:srgbClr val="FFFFFF"/>
                 </a:solidFill>
@@ -8267,7 +8263,7 @@
               <a:buNone/>
             </a:pPr>
             <a:r>
-              <a:rPr lang="en-US" sz="2000" dirty="0">
+              <a:rPr lang="en-US" sz="2000" b="1" dirty="0">
                 <a:solidFill>
                   <a:srgbClr val="FFFFFF"/>
                 </a:solidFill>
@@ -8334,7 +8330,7 @@
               <a:buNone/>
             </a:pPr>
             <a:r>
-              <a:rPr lang="en-US" sz="2000" dirty="0">
+              <a:rPr lang="en-US" sz="2000" b="1" dirty="0">
                 <a:solidFill>
                   <a:srgbClr val="FFFFFF"/>
                 </a:solidFill>
@@ -8401,7 +8397,7 @@
               <a:buNone/>
             </a:pPr>
             <a:r>
-              <a:rPr lang="en-US" sz="2000" dirty="0">
+              <a:rPr lang="en-US" sz="2000" b="1" dirty="0">
                 <a:solidFill>
                   <a:srgbClr val="FFFFFF"/>
                 </a:solidFill>
@@ -8468,7 +8464,7 @@
               <a:buNone/>
             </a:pPr>
             <a:r>
-              <a:rPr lang="en-US" sz="2000" dirty="0">
+              <a:rPr lang="en-US" sz="2000" b="1" dirty="0">
                 <a:solidFill>
                   <a:srgbClr val="FFFFFF"/>
                 </a:solidFill>
@@ -8535,7 +8531,7 @@
               <a:buNone/>
             </a:pPr>
             <a:r>
-              <a:rPr lang="en-US" sz="2000" dirty="0">
+              <a:rPr lang="en-US" sz="2000" b="1" dirty="0">
                 <a:solidFill>
                   <a:srgbClr val="FFFFFF"/>
                 </a:solidFill>

</xml_diff>

<commit_message>
Refresh version text and marketing copy for 0.21.0
Co-Authored-By: Claude Opus 5.5 <noreply@anthropic.com>
Claude-Session: https://claude.ai/code/session_011Mu8TrA4uLjwSH9YN5Lkj6
</commit_message>
<xml_diff>
--- a/marketing/output/deck/vixl-pitch-deck.pptx
+++ b/marketing/output/deck/vixl-pitch-deck.pptx
@@ -1040,7 +1040,7 @@
         <p:spPr>
           <a:xfrm>
             <a:off x="889000" y="5280620"/>
-            <a:ext cx="5246688" cy="269280"/>
+            <a:ext cx="5199062" cy="269280"/>
           </a:xfrm>
           <a:prstGeom prst="rect">
             <a:avLst/>
@@ -1068,7 +1068,7 @@
                 <a:ea typeface="Inter"/>
                 <a:cs typeface="Inter"/>
               </a:rPr>
-              <a:t>Release 0.20.0  ·  MCP · CLI · Python · REST</a:t>
+              <a:t>Release 0.21.0  ·  MCP · CLI · Python · REST</a:t>
             </a:r>
             <a:endParaRPr lang="en-US" sz="1600" dirty="0"/>
           </a:p>
@@ -2783,7 +2783,7 @@
         <p:spPr>
           <a:xfrm>
             <a:off x="1168400" y="3597988"/>
-            <a:ext cx="5818188" cy="281862"/>
+            <a:ext cx="5842000" cy="281862"/>
           </a:xfrm>
           <a:prstGeom prst="rect">
             <a:avLst/>
@@ -2811,7 +2811,7 @@
                 <a:ea typeface="Inter"/>
                 <a:cs typeface="Inter"/>
               </a:rPr>
-              <a:t>179 operations, up to 10,000 per atomic batch</a:t>
+              <a:t>180 operations, up to 10,000 per atomic batch</a:t>
             </a:r>
             <a:endParaRPr lang="en-US" sz="1700" dirty="0"/>
           </a:p>

</xml_diff>

<commit_message>
Rewrite Vixl's copy and marketing pack in one casual voice
Settle on one positioning line ("Ideas become editable." / a design engine
for AI agents. Programmable, editable, checked.) and apply it to the README,
pyproject, CLI help, plugin and desktop-extension listings, docs intros and
the skill, replacing three competing descriptors.

Rewrite the marketing pack's artwork text, deck slides and speaker notes,
captions, alt text, campaign CSV and demo script in a more casual voice,
then rebuild the pack; build checks and marketing/verify.py pass.

Add docs/brand-voice.md with the pillars, voice rules, banned words and
where each piece of copy lives.

Co-Authored-By: Claude Opus 5.5 <noreply@anthropic.com>
Claude-Session: https://claude.ai/code/session_01XZQLvD3Psv1ejZcCqEUV5b
</commit_message>
<xml_diff>
--- a/marketing/output/deck/vixl-pitch-deck.pptx
+++ b/marketing/output/deck/vixl-pitch-deck.pptx
@@ -463,7 +463,7 @@
           <a:p>
             <a:r>
               <a:rPr lang="en-US" dirty="0"/>
-              <a:t>Vixl is a programmable design studio for AI agents. It turns graphics, documents and motion into layered files you can inspect, revise and deliver. This deck was authored with Vixl.</a:t>
+              <a:t>Vixl is a design engine for AI agents. Your agent builds graphics, documents and motion out of real layers, Vixl checks the work, and you get a file you can still change next week. Fun fact: this deck was made with Vixl.</a:t>
             </a:r>
           </a:p>
         </p:txBody>
@@ -581,7 +581,7 @@
           <a:p>
             <a:r>
               <a:rPr lang="en-US" dirty="0"/>
-              <a:t>Supported vectors stay vector in SVG/PDF where possible; some features use reported raster fallbacks. PPTX preserves supported editable shapes, text, tables and charts. PSD export is layered pixels, not native editable type. CMYK is an export setting; a printer should confirm the chosen profile.</a:t>
+              <a:t>Supported vectors stay vector in SVG/PDF where possible; some features use reported raster fallbacks. PPTX preserves supported editable shapes, text, tables and charts. PSD export is layered pixels, not native editable type. CMYK is an export setting; ask your printer to confirm the profile.</a:t>
             </a:r>
           </a:p>
         </p:txBody>
@@ -699,7 +699,7 @@
           <a:p>
             <a:r>
               <a:rPr lang="en-US" dirty="0"/>
-              <a:t>The .vixl master keeps editable content, settings and branching history. Raster images remain pixels; text, supported shapes and paths remain editable. Deliver the master alongside the formats people need.</a:t>
+              <a:t>Ask for a poster and most tools hand you a picture of a poster. The .vixl master keeps the content, settings and branching history instead. Raster images stay pixels; text, supported shapes and paths stay editable. Send the master along with whatever formats people asked for.</a:t>
             </a:r>
           </a:p>
         </p:txBody>
@@ -758,7 +758,7 @@
           <a:p>
             <a:r>
               <a:rPr lang="en-US" dirty="0"/>
-              <a:t>Inspect, apply, check, preview and export. The diagram is made from Vixl's diagram operation, with editable nodes, routed paths and text. Automated checks complement visual review; they do not judge taste.</a:t>
+              <a:t>Inspect, apply, check, preview and export. Each step tells the agent what went wrong while it is still cheap to fix. The diagram is Vixl's own diagram operation: editable nodes, routed paths and text. Checks back up visual review; they do not judge taste.</a:t>
             </a:r>
           </a:p>
         </p:txBody>
@@ -817,7 +817,7 @@
           <a:p>
             <a:r>
               <a:rPr lang="en-US" dirty="0"/>
-              <a:t>These examples are real outputs in this repository: print layout, generative painting, a pixel game, data graphics, character animation and photo editing. They show different workflows rather than usage statistics.</a:t>
+              <a:t>Every one of these is a real output in this repository: a print layout, a generative painting, a pixel game, data graphics, character animation and a photo edit. They show range, not usage statistics.</a:t>
             </a:r>
           </a:p>
         </p:txBody>
@@ -876,7 +876,7 @@
           <a:p>
             <a:r>
               <a:rPr lang="en-US" dirty="0"/>
-              <a:t>This is illustrative workflow data, not a customer result or performance claim. Vixl binds the chart to categories and series. In the PowerPoint export it is a native chart with an embedded workbook. Open PowerPoint's Edit Data command to inspect it.</a:t>
+              <a:t>Illustrative workflow data, not a customer result or performance claim. Vixl binds the chart to categories and series, so new numbers do not mean a new chart. In the PowerPoint export it is a native chart with an embedded workbook: open Edit Data and poke around.</a:t>
             </a:r>
           </a:p>
         </p:txBody>
@@ -935,7 +935,7 @@
           <a:p>
             <a:r>
               <a:rPr lang="en-US" dirty="0"/>
-              <a:t>The included social campaign is a typed recipe. Its inputs supply headline, description and accent. Production instantiates three rows, runs the saved design suite and exports the checked variants. Use the supplied CSV and production request as a starting point.</a:t>
+              <a:t>The included social campaign is a typed recipe: headline, description and accent go in, posts come out. Production fills in three CSV rows, runs the saved design suite and exports only the variants that pass. Nobody copies and pastes anything. Start from the supplied CSV and production request.</a:t>
             </a:r>
           </a:p>
         </p:txBody>
@@ -994,7 +994,7 @@
           <a:p>
             <a:r>
               <a:rPr lang="en-US" dirty="0"/>
-              <a:t>Vixl supports timeline tracks, cameras, audio and rigged joint pose keys. The app demo in this kit ships ready, creating and delivered states with light/dark themes, explicit transitions, editable masters and reduced-motion PNGs. The teaser is an editable timeline exported to MP4 and GIF.</a:t>
+              <a:t>Vixl has timeline tracks, cameras, audio and rigged joint pose keys. The app demo in this kit ships ready, creating and delivered states with light and dark themes, explicit transitions, editable masters and reduced-motion PNGs. The teaser is an editable timeline exported to MP4 and GIF.</a:t>
             </a:r>
           </a:p>
         </p:txBody>
@@ -1053,7 +1053,7 @@
           <a:p>
             <a:r>
               <a:rPr lang="en-US" dirty="0"/>
-              <a:t>Design checks cover bounds, flow, contrast, fonts and other selected concerns. Saved suites can encode margins, hierarchy and spacing. Proof pages collect previews and findings offline. A passing check proves its rules, so a person or agent still needs to review the rendered design.</a:t>
+              <a:t>Design checks cover bounds, flow, contrast, fonts and more. Saved suites turn margins, hierarchy and spacing into rules that pass or fail. Proof pages collect previews and findings offline. A passing check proves its rules, not your taste, so someone still looks at the render.</a:t>
             </a:r>
           </a:p>
         </p:txBody>
@@ -1112,7 +1112,7 @@
           <a:p>
             <a:r>
               <a:rPr lang="en-US" dirty="0"/>
-              <a:t>Unpack a .vixl master into stable current-state JSON and hashed assets for Git review. Pack it back into a document after edits. Branching history, project groups and reusable libraries support collaboration. The included campaign has an unpacked source folder to inspect.</a:t>
+              <a:t>Unpack a .vixl master into stable JSON and hashed assets, review the diff in Git, then pack it back into a document. Branching history, project groups and reusable libraries cover the rest of teamwork. The included campaign has an unpacked source folder you can browse.</a:t>
             </a:r>
           </a:p>
         </p:txBody>
@@ -2092,7 +2092,7 @@
                 <a:ea typeface="JetBrains Mono"/>
                 <a:cs typeface="JetBrains Mono"/>
               </a:rPr>
-              <a:t>VIXL / A DESIGN STUDIO FOR AI AGENTS</a:t>
+              <a:t>VIXL / A DESIGN ENGINE FOR AI AGENTS</a:t>
             </a:r>
             <a:endParaRPr lang="en-US" sz="1400" dirty="0"/>
           </a:p>
@@ -2537,7 +2537,7 @@
                 <a:ea typeface="Inter"/>
                 <a:cs typeface="Inter"/>
               </a:rPr>
-              <a:t>Graphics. Documents. Motion.</a:t>
+              <a:t>Programmable. Editable. Checked.</a:t>
             </a:r>
             <a:endParaRPr lang="en-US" sz="2200" dirty="0"/>
           </a:p>
@@ -3642,7 +3642,7 @@
         <p:spPr>
           <a:xfrm>
             <a:off x="1117600" y="3952680"/>
-            <a:ext cx="1955800" cy="574870"/>
+            <a:ext cx="1955800" cy="854270"/>
           </a:xfrm>
           <a:prstGeom prst="rect">
             <a:avLst/>
@@ -3676,7 +3676,7 @@
                 <a:ea typeface="Inter"/>
                 <a:cs typeface="Inter"/>
               </a:rPr>
-              <a:t>Connect an agent to the workspace.</a:t>
+              <a:t>Hand the workspace to your agent.</a:t>
             </a:r>
             <a:endParaRPr lang="en-US" sz="1700" dirty="0"/>
           </a:p>
@@ -3835,7 +3835,7 @@
                 <a:ea typeface="Inter"/>
                 <a:cs typeface="Inter"/>
               </a:rPr>
-              <a:t>Script and batch from a terminal.</a:t>
+              <a:t>Script it, batch it, run it in CI.</a:t>
             </a:r>
             <a:endParaRPr lang="en-US" sz="1700" dirty="0"/>
           </a:p>
@@ -3994,7 +3994,7 @@
                 <a:ea typeface="Inter"/>
                 <a:cs typeface="Inter"/>
               </a:rPr>
-              <a:t>Compose files from code and data.</a:t>
+              <a:t>Generate designs from code and data.</a:t>
             </a:r>
             <a:endParaRPr lang="en-US" sz="1700" dirty="0"/>
           </a:p>
@@ -4153,7 +4153,7 @@
                 <a:ea typeface="Inter"/>
                 <a:cs typeface="Inter"/>
               </a:rPr>
-              <a:t>Integrate with web services.</a:t>
+              <a:t>Plug it into web services.</a:t>
             </a:r>
             <a:endParaRPr lang="en-US" sz="1700" dirty="0"/>
           </a:p>
@@ -5019,7 +5019,7 @@
         <p:spPr>
           <a:xfrm>
             <a:off x="889000" y="1316078"/>
-            <a:ext cx="10707688" cy="550822"/>
+            <a:ext cx="11279188" cy="550822"/>
           </a:xfrm>
           <a:prstGeom prst="rect">
             <a:avLst/>
@@ -5053,7 +5053,7 @@
                 <a:ea typeface="Inter Tight"/>
                 <a:cs typeface="Inter Tight"/>
               </a:rPr>
-              <a:t>Send the formats </a:t>
+              <a:t>Whatever format </a:t>
             </a:r>
             <a:r>
               <a:rPr lang="en-US" sz="4700" b="1" dirty="0">
@@ -5064,7 +5064,7 @@
                 <a:ea typeface="Inter Tight"/>
                 <a:cs typeface="Inter Tight"/>
               </a:rPr>
-              <a:t>people need.</a:t>
+              <a:t>they asked for.</a:t>
             </a:r>
             <a:endParaRPr lang="en-US" sz="4700" dirty="0"/>
           </a:p>
@@ -6359,8 +6359,8 @@
         </p:nvSpPr>
         <p:spPr>
           <a:xfrm>
-            <a:off x="889000" y="559994"/>
-            <a:ext cx="1873250" cy="214706"/>
+            <a:off x="889000" y="559816"/>
+            <a:ext cx="1231900" cy="208534"/>
           </a:xfrm>
           <a:prstGeom prst="rect">
             <a:avLst/>
@@ -6388,7 +6388,7 @@
                 <a:ea typeface="JetBrains Mono"/>
                 <a:cs typeface="JetBrains Mono"/>
               </a:rPr>
-              <a:t>START CREATING</a:t>
+              <a:t>YOUR TURN</a:t>
             </a:r>
             <a:endParaRPr lang="en-US" sz="1400" dirty="0"/>
           </a:p>
@@ -6407,7 +6407,7 @@
         <p:spPr>
           <a:xfrm>
             <a:off x="889000" y="1316078"/>
-            <a:ext cx="11215688" cy="550822"/>
+            <a:ext cx="9485312" cy="550822"/>
           </a:xfrm>
           <a:prstGeom prst="rect">
             <a:avLst/>
@@ -6441,7 +6441,7 @@
                 <a:ea typeface="Inter Tight"/>
                 <a:cs typeface="Inter Tight"/>
               </a:rPr>
-              <a:t>Give your agent a </a:t>
+              <a:t>Give your agent </a:t>
             </a:r>
             <a:r>
               <a:rPr lang="en-US" sz="4700" b="1" dirty="0">
@@ -6452,7 +6452,7 @@
                 <a:ea typeface="Inter Tight"/>
                 <a:cs typeface="Inter Tight"/>
               </a:rPr>
-              <a:t>design studio.</a:t>
+              <a:t>real layers.</a:t>
             </a:r>
             <a:endParaRPr lang="en-US" sz="4700" dirty="0"/>
           </a:p>
@@ -7756,7 +7756,7 @@
         <p:spPr>
           <a:xfrm>
             <a:off x="889000" y="1316078"/>
-            <a:ext cx="8374062" cy="550822"/>
+            <a:ext cx="9366250" cy="550822"/>
           </a:xfrm>
           <a:prstGeom prst="rect">
             <a:avLst/>
@@ -7790,7 +7790,7 @@
                 <a:ea typeface="Inter Tight"/>
                 <a:cs typeface="Inter Tight"/>
               </a:rPr>
-              <a:t>A design is a </a:t>
+              <a:t>Not a picture. </a:t>
             </a:r>
             <a:r>
               <a:rPr lang="en-US" sz="4700" b="1" dirty="0">
@@ -7801,7 +7801,7 @@
                 <a:ea typeface="Inter Tight"/>
                 <a:cs typeface="Inter Tight"/>
               </a:rPr>
-              <a:t>document.</a:t>
+              <a:t>A document.</a:t>
             </a:r>
             <a:endParaRPr lang="en-US" sz="4700" dirty="0"/>
           </a:p>
@@ -7926,7 +7926,7 @@
         <p:spPr>
           <a:xfrm>
             <a:off x="1117600" y="3952680"/>
-            <a:ext cx="2844800" cy="574870"/>
+            <a:ext cx="2844800" cy="854270"/>
           </a:xfrm>
           <a:prstGeom prst="rect">
             <a:avLst/>
@@ -7960,7 +7960,7 @@
                 <a:ea typeface="Inter"/>
                 <a:cs typeface="Inter"/>
               </a:rPr>
-              <a:t>Text, vector paths, images, masks and effects.</a:t>
+              <a:t>Text, paths, images, masks and effects. All still editable.</a:t>
             </a:r>
             <a:endParaRPr lang="en-US" sz="1700" dirty="0"/>
           </a:p>
@@ -8085,7 +8085,7 @@
         <p:spPr>
           <a:xfrm>
             <a:off x="4673600" y="3952680"/>
-            <a:ext cx="2844800" cy="854270"/>
+            <a:ext cx="2844800" cy="574870"/>
           </a:xfrm>
           <a:prstGeom prst="rect">
             <a:avLst/>
@@ -8119,7 +8119,7 @@
                 <a:ea typeface="Inter"/>
                 <a:cs typeface="Inter"/>
               </a:rPr>
-              <a:t>Groups, variables, pages, layouts and reusable components.</a:t>
+              <a:t>Groups, variables, pages, layouts and reusable parts.</a:t>
             </a:r>
             <a:endParaRPr lang="en-US" sz="1700" dirty="0"/>
           </a:p>
@@ -8278,7 +8278,7 @@
                 <a:ea typeface="Inter"/>
                 <a:cs typeface="Inter"/>
               </a:rPr>
-              <a:t>Undo, checkpoints, branches and document diffs.</a:t>
+              <a:t>Undo, checkpoints, branches and diffs. Go back in time.</a:t>
             </a:r>
             <a:endParaRPr lang="en-US" sz="1700" dirty="0"/>
           </a:p>
@@ -9144,7 +9144,7 @@
         <p:spPr>
           <a:xfrm>
             <a:off x="889000" y="1316078"/>
-            <a:ext cx="8326438" cy="550822"/>
+            <a:ext cx="8278812" cy="550822"/>
           </a:xfrm>
           <a:prstGeom prst="rect">
             <a:avLst/>
@@ -9178,7 +9178,7 @@
                 <a:ea typeface="Inter Tight"/>
                 <a:cs typeface="Inter Tight"/>
               </a:rPr>
-              <a:t>Feedback at </a:t>
+              <a:t>Look before </a:t>
             </a:r>
             <a:r>
               <a:rPr lang="en-US" sz="4700" b="1" dirty="0">
@@ -9189,7 +9189,7 @@
                 <a:ea typeface="Inter Tight"/>
                 <a:cs typeface="Inter Tight"/>
               </a:rPr>
-              <a:t>every step.</a:t>
+              <a:t>you export.</a:t>
             </a:r>
             <a:endParaRPr lang="en-US" sz="4700" dirty="0"/>
           </a:p>
@@ -9840,7 +9840,7 @@
                 <a:ea typeface="Inter"/>
                 <a:cs typeface="Inter"/>
               </a:rPr>
-              <a:t>Read the structure. Apply atomic edits. Check requirements.</a:t>
+              <a:t>Read the canvas. Make atomic edits. Run the checks.</a:t>
             </a:r>
             <a:endParaRPr lang="en-US" sz="1800" dirty="0"/>
           </a:p>
@@ -9866,7 +9866,7 @@
                 <a:ea typeface="Inter"/>
                 <a:cs typeface="Inter"/>
               </a:rPr>
-              <a:t>Render and review the design. Export the files.</a:t>
+              <a:t>Look at the render. Then ship the files.</a:t>
             </a:r>
             <a:endParaRPr lang="en-US" sz="1800" dirty="0"/>
           </a:p>
@@ -10685,7 +10685,7 @@
         <p:spPr>
           <a:xfrm>
             <a:off x="889000" y="559994"/>
-            <a:ext cx="3206750" cy="214706"/>
+            <a:ext cx="4270375" cy="240106"/>
           </a:xfrm>
           <a:prstGeom prst="rect">
             <a:avLst/>
@@ -10713,7 +10713,7 @@
                 <a:ea typeface="JetBrains Mono"/>
                 <a:cs typeface="JetBrains Mono"/>
               </a:rPr>
-              <a:t>A BROAD CREATIVE TOOLSET</a:t>
+              <a:t>SAME ENGINE, VERY DIFFERENT JOBS</a:t>
             </a:r>
             <a:endParaRPr lang="en-US" sz="1400" dirty="0"/>
           </a:p>
@@ -12423,7 +12423,7 @@
         <p:spPr>
           <a:xfrm>
             <a:off x="889000" y="1316078"/>
-            <a:ext cx="10120312" cy="550822"/>
+            <a:ext cx="9683750" cy="550822"/>
           </a:xfrm>
           <a:prstGeom prst="rect">
             <a:avLst/>
@@ -12457,7 +12457,7 @@
                 <a:ea typeface="Inter Tight"/>
                 <a:cs typeface="Inter Tight"/>
               </a:rPr>
-              <a:t>Edit the data. </a:t>
+              <a:t>New numbers? </a:t>
             </a:r>
             <a:r>
               <a:rPr lang="en-US" sz="4700" b="1" dirty="0">
@@ -12468,7 +12468,7 @@
                 <a:ea typeface="Inter Tight"/>
                 <a:cs typeface="Inter Tight"/>
               </a:rPr>
-              <a:t>Keep the chart.</a:t>
+              <a:t>Same chart.</a:t>
             </a:r>
             <a:endParaRPr lang="en-US" sz="4700" dirty="0"/>
           </a:p>
@@ -12568,7 +12568,7 @@
         <p:spPr>
           <a:xfrm>
             <a:off x="7874000" y="2593494"/>
-            <a:ext cx="3302000" cy="1743556"/>
+            <a:ext cx="3302000" cy="2321406"/>
           </a:xfrm>
           <a:prstGeom prst="rect">
             <a:avLst/>
@@ -12602,7 +12602,7 @@
                 <a:ea typeface="Inter"/>
                 <a:cs typeface="Inter"/>
               </a:rPr>
-              <a:t>Change values with chart-data.</a:t>
+              <a:t>Change the values with chart-data.</a:t>
             </a:r>
             <a:endParaRPr lang="en-US" sz="1750" dirty="0"/>
           </a:p>
@@ -12643,7 +12643,7 @@
                 <a:ea typeface="Inter"/>
                 <a:cs typeface="Inter"/>
               </a:rPr>
-              <a:t>Vixl updates the scale, bars, labels and totals.</a:t>
+              <a:t>Scale, bars, labels and totals follow along.</a:t>
             </a:r>
             <a:endParaRPr lang="en-US" sz="1750" dirty="0"/>
           </a:p>
@@ -12684,7 +12684,7 @@
                 <a:ea typeface="Inter"/>
                 <a:cs typeface="Inter"/>
               </a:rPr>
-              <a:t>PPTX includes the data table.</a:t>
+              <a:t>In PowerPoint, hit Edit Data. It is all there.</a:t>
             </a:r>
             <a:endParaRPr lang="en-US" sz="1750" dirty="0"/>
           </a:p>
@@ -13550,7 +13550,7 @@
         <p:spPr>
           <a:xfrm>
             <a:off x="889000" y="1316078"/>
-            <a:ext cx="10334625" cy="550822"/>
+            <a:ext cx="9636125" cy="550822"/>
           </a:xfrm>
           <a:prstGeom prst="rect">
             <a:avLst/>
@@ -13595,7 +13595,7 @@
                 <a:ea typeface="Inter Tight"/>
                 <a:cs typeface="Inter Tight"/>
               </a:rPr>
-              <a:t>Useful variations.</a:t>
+              <a:t>Plenty of posts.</a:t>
             </a:r>
             <a:endParaRPr lang="en-US" sz="4700" dirty="0"/>
           </a:p>
@@ -14681,7 +14681,7 @@
         <p:spPr>
           <a:xfrm>
             <a:off x="889000" y="1316078"/>
-            <a:ext cx="7754938" cy="1103272"/>
+            <a:ext cx="5476875" cy="1103272"/>
           </a:xfrm>
           <a:prstGeom prst="rect">
             <a:avLst/>
@@ -14715,7 +14715,7 @@
                 <a:ea typeface="Inter Tight"/>
                 <a:cs typeface="Inter Tight"/>
               </a:rPr>
-              <a:t>Animate the idea.</a:t>
+              <a:t>Make it move.</a:t>
             </a:r>
             <a:endParaRPr lang="en-US" sz="4700" dirty="0"/>
           </a:p>
@@ -14741,7 +14741,7 @@
                 <a:ea typeface="Inter Tight"/>
                 <a:cs typeface="Inter Tight"/>
               </a:rPr>
-              <a:t>Package the behavior.</a:t>
+              <a:t>Ship the states.</a:t>
             </a:r>
             <a:endParaRPr lang="en-US" sz="4700" dirty="0"/>
           </a:p>
@@ -14900,7 +14900,7 @@
                 <a:ea typeface="Inter"/>
                 <a:cs typeface="Inter"/>
               </a:rPr>
-              <a:t>Keyframes, motion recipes, character poses, cameras and audio.</a:t>
+              <a:t>Keyframes, motion recipes, posable characters, cameras and audio.</a:t>
             </a:r>
             <a:endParaRPr lang="en-US" sz="1700" dirty="0"/>
           </a:p>
@@ -15059,7 +15059,7 @@
                 <a:ea typeface="Inter"/>
                 <a:cs typeface="Inter"/>
               </a:rPr>
-              <a:t>GIF, animated WebP, APNG, MP4 and other supported timeline formats.</a:t>
+              <a:t>GIF, animated WebP, APNG, MP4 and other timeline formats.</a:t>
             </a:r>
             <a:endParaRPr lang="en-US" sz="1700" dirty="0"/>
           </a:p>
@@ -16036,8 +16036,8 @@
         </p:nvSpPr>
         <p:spPr>
           <a:xfrm>
-            <a:off x="889000" y="559816"/>
-            <a:ext cx="2135188" cy="208534"/>
+            <a:off x="889000" y="559994"/>
+            <a:ext cx="3071812" cy="214706"/>
           </a:xfrm>
           <a:prstGeom prst="rect">
             <a:avLst/>
@@ -16065,7 +16065,7 @@
                 <a:ea typeface="JetBrains Mono"/>
                 <a:cs typeface="JetBrains Mono"/>
               </a:rPr>
-              <a:t>CHECKED DELIVERY</a:t>
+              <a:t>CHECKED BEFORE IT SHIPS</a:t>
             </a:r>
             <a:endParaRPr lang="en-US" sz="1400" dirty="0"/>
           </a:p>
@@ -16084,7 +16084,7 @@
         <p:spPr>
           <a:xfrm>
             <a:off x="889000" y="1316078"/>
-            <a:ext cx="11326812" cy="550822"/>
+            <a:ext cx="8159750" cy="550822"/>
           </a:xfrm>
           <a:prstGeom prst="rect">
             <a:avLst/>
@@ -16118,7 +16118,7 @@
                 <a:ea typeface="Inter Tight"/>
                 <a:cs typeface="Inter Tight"/>
               </a:rPr>
-              <a:t>Make requirements </a:t>
+              <a:t>Write the brief </a:t>
             </a:r>
             <a:r>
               <a:rPr lang="en-US" sz="4700" b="1" dirty="0">
@@ -16129,7 +16129,7 @@
                 <a:ea typeface="Inter Tight"/>
                 <a:cs typeface="Inter Tight"/>
               </a:rPr>
-              <a:t>measurable.</a:t>
+              <a:t>as tests.</a:t>
             </a:r>
             <a:endParaRPr lang="en-US" sz="4700" dirty="0"/>
           </a:p>
@@ -16288,7 +16288,7 @@
                 <a:ea typeface="Inter"/>
                 <a:cs typeface="Inter"/>
               </a:rPr>
-              <a:t>Save layout and delivery requirements as test suites.</a:t>
+              <a:t>Turn margins, contrast and hierarchy into saved suites.</a:t>
             </a:r>
             <a:endParaRPr lang="en-US" sz="1700" dirty="0"/>
           </a:p>
@@ -16413,7 +16413,7 @@
         <p:spPr>
           <a:xfrm>
             <a:off x="4673600" y="3952680"/>
-            <a:ext cx="2844800" cy="854270"/>
+            <a:ext cx="2844800" cy="574870"/>
           </a:xfrm>
           <a:prstGeom prst="rect">
             <a:avLst/>
@@ -16447,7 +16447,7 @@
                 <a:ea typeface="Inter"/>
                 <a:cs typeface="Inter"/>
               </a:rPr>
-              <a:t>Run checks, review findings and look at actual previews.</a:t>
+              <a:t>Run the checks, read the findings, then actually look.</a:t>
             </a:r>
             <a:endParaRPr lang="en-US" sz="1700" dirty="0"/>
           </a:p>
@@ -16606,7 +16606,7 @@
                 <a:ea typeface="Inter"/>
                 <a:cs typeface="Inter"/>
               </a:rPr>
-              <a:t>Use offline proof pages or a live REST review session.</a:t>
+              <a:t>Offline proof pages or a live REST review session.</a:t>
             </a:r>
             <a:endParaRPr lang="en-US" sz="1700" dirty="0"/>
           </a:p>
@@ -17472,7 +17472,7 @@
         <p:spPr>
           <a:xfrm>
             <a:off x="889000" y="1316078"/>
-            <a:ext cx="11152188" cy="550822"/>
+            <a:ext cx="10080625" cy="550822"/>
           </a:xfrm>
           <a:prstGeom prst="rect">
             <a:avLst/>
@@ -17506,7 +17506,7 @@
                 <a:ea typeface="Inter Tight"/>
                 <a:cs typeface="Inter Tight"/>
               </a:rPr>
-              <a:t>Designs belong in the </a:t>
+              <a:t>Designs get </a:t>
             </a:r>
             <a:r>
               <a:rPr lang="en-US" sz="4700" b="1" dirty="0">
@@ -17517,7 +17517,7 @@
                 <a:ea typeface="Inter Tight"/>
                 <a:cs typeface="Inter Tight"/>
               </a:rPr>
-              <a:t>workflow.</a:t>
+              <a:t>code review too.</a:t>
             </a:r>
             <a:endParaRPr lang="en-US" sz="4700" dirty="0"/>
           </a:p>
@@ -17835,7 +17835,7 @@
                 <a:ea typeface="Inter"/>
                 <a:cs typeface="Inter"/>
               </a:rPr>
-              <a:t>Branches, explicit merges, project groups and reusable libraries.</a:t>
+              <a:t>Branches, explicit merges, project groups and shared libraries.</a:t>
             </a:r>
             <a:endParaRPr lang="en-US" sz="1700" dirty="0"/>
           </a:p>
@@ -17960,7 +17960,7 @@
         <p:spPr>
           <a:xfrm>
             <a:off x="8229600" y="3952680"/>
-            <a:ext cx="2844800" cy="854270"/>
+            <a:ext cx="2844800" cy="574870"/>
           </a:xfrm>
           <a:prstGeom prst="rect">
             <a:avLst/>
@@ -17994,7 +17994,7 @@
                 <a:ea typeface="Inter"/>
                 <a:cs typeface="Inter"/>
               </a:rPr>
-              <a:t>Embedded content and fonts, plus the editable master.</a:t>
+              <a:t>Fonts and content travel inside the editable master.</a:t>
             </a:r>
             <a:endParaRPr lang="en-US" sz="1700" dirty="0"/>
           </a:p>

</xml_diff>

<commit_message>
Replace the Digital Shift logo with the Ripple identity
Add the Ripple kit in assets/brand/ripple, generated by its build.py:
wordmarks and symbols in four colour versions (SVG, PNG, PDF), app,
social and favicon artwork with a simplified small-size symbol, the
animated wordmark (GIF, WebP, MP4) and editable masters.

Point the README, browser review artwork, Windows icon, Claude Desktop
bundle icon, marketing kit and the brand SVG import test at the new kit,
and rebuild the marketing outputs. The Digital Shift kit stays in place,
marked retired. marketing/build.py now overwrites its own masters on
rebuild.

Co-Authored-By: Claude Opus 5.5 <noreply@anthropic.com>
Claude-Session: https://claude.ai/code/session_01DjoGj4HkVxDaDvysZgGC4c
</commit_message>
<xml_diff>
--- a/marketing/output/deck/vixl-pitch-deck.pptx
+++ b/marketing/output/deck/vixl-pitch-deck.pptx
@@ -834,9 +834,14 @@
                   <a:alpha val="37647"/>
                 </a:srgbClr>
               </a:gs>
-              <a:gs pos="60000">
+              <a:gs pos="42426">
                 <a:srgbClr val="3575EE">
                   <a:alpha val="6275"/>
+                </a:srgbClr>
+              </a:gs>
+              <a:gs pos="70711">
+                <a:srgbClr val="3575EE">
+                  <a:alpha val="0"/>
                 </a:srgbClr>
               </a:gs>
               <a:gs pos="100000">
@@ -938,8 +943,8 @@
         </p:nvSpPr>
         <p:spPr>
           <a:xfrm>
-            <a:off x="889000" y="2549021"/>
-            <a:ext cx="7262812" cy="2423029"/>
+            <a:off x="889000" y="2746220"/>
+            <a:ext cx="7262812" cy="1965480"/>
           </a:xfrm>
           <a:prstGeom prst="rect">
             <a:avLst/>
@@ -954,7 +959,7 @@
           <a:p>
             <a:pPr algn="l">
               <a:lnSpc>
-                <a:spcPts val="6434"/>
+                <a:spcPts val="5152"/>
               </a:lnSpc>
               <a:spcBef>
                 <a:spcPts val="0"/>
@@ -980,7 +985,7 @@
           <a:p>
             <a:pPr algn="l">
               <a:lnSpc>
-                <a:spcPts val="6434"/>
+                <a:spcPts val="5152"/>
               </a:lnSpc>
               <a:spcBef>
                 <a:spcPts val="0"/>
@@ -1006,7 +1011,7 @@
           <a:p>
             <a:pPr algn="l">
               <a:lnSpc>
-                <a:spcPts val="6434"/>
+                <a:spcPts val="5152"/>
               </a:lnSpc>
               <a:spcBef>
                 <a:spcPts val="0"/>
@@ -1039,8 +1044,8 @@
         </p:nvSpPr>
         <p:spPr>
           <a:xfrm>
-            <a:off x="889000" y="5280620"/>
-            <a:ext cx="5199062" cy="269280"/>
+            <a:off x="889000" y="4994870"/>
+            <a:ext cx="5199062" cy="294680"/>
           </a:xfrm>
           <a:prstGeom prst="rect">
             <a:avLst/>
@@ -1055,7 +1060,7 @@
           <a:p>
             <a:pPr algn="l">
               <a:lnSpc>
-                <a:spcPts val="2136"/>
+                <a:spcPts val="2336"/>
               </a:lnSpc>
               <a:buNone/>
             </a:pPr>
@@ -1166,8 +1171,8 @@
         </p:nvSpPr>
         <p:spPr>
           <a:xfrm>
-            <a:off x="11112500" y="6180328"/>
-            <a:ext cx="323850" cy="182372"/>
+            <a:off x="11112500" y="6186678"/>
+            <a:ext cx="323850" cy="176022"/>
           </a:xfrm>
           <a:prstGeom prst="rect">
             <a:avLst/>
@@ -1182,7 +1187,7 @@
           <a:p>
             <a:pPr algn="l">
               <a:lnSpc>
-                <a:spcPts val="1784"/>
+                <a:spcPts val="1734"/>
               </a:lnSpc>
               <a:buNone/>
             </a:pPr>
@@ -1209,8 +1214,8 @@
         </p:nvSpPr>
         <p:spPr>
           <a:xfrm>
-            <a:off x="889000" y="563372"/>
-            <a:ext cx="1365250" cy="198628"/>
+            <a:off x="889000" y="569722"/>
+            <a:ext cx="1365250" cy="192278"/>
           </a:xfrm>
           <a:prstGeom prst="rect">
             <a:avLst/>
@@ -1225,7 +1230,7 @@
           <a:p>
             <a:pPr algn="l">
               <a:lnSpc>
-                <a:spcPts val="1916"/>
+                <a:spcPts val="1866"/>
               </a:lnSpc>
               <a:buNone/>
             </a:pPr>
@@ -1256,8 +1261,8 @@
         </p:nvSpPr>
         <p:spPr>
           <a:xfrm>
-            <a:off x="889000" y="956604"/>
-            <a:ext cx="7881938" cy="1380196"/>
+            <a:off x="889000" y="1129260"/>
+            <a:ext cx="7881938" cy="1124990"/>
           </a:xfrm>
           <a:prstGeom prst="rect">
             <a:avLst/>
@@ -1272,7 +1277,7 @@
           <a:p>
             <a:pPr algn="l">
               <a:lnSpc>
-                <a:spcPts val="5543"/>
+                <a:spcPts val="4416"/>
               </a:lnSpc>
               <a:spcBef>
                 <a:spcPts val="0"/>
@@ -1298,7 +1303,7 @@
           <a:p>
             <a:pPr algn="l">
               <a:lnSpc>
-                <a:spcPts val="5543"/>
+                <a:spcPts val="4416"/>
               </a:lnSpc>
               <a:spcBef>
                 <a:spcPts val="0"/>
@@ -1342,7 +1347,7 @@
         </p:nvSpPr>
         <p:spPr>
           <a:xfrm>
-            <a:off x="889000" y="2908300"/>
+            <a:off x="889000" y="2825750"/>
             <a:ext cx="3302000" cy="2095500"/>
           </a:xfrm>
           <a:prstGeom prst="roundRect">
@@ -1366,8 +1371,8 @@
         </p:nvSpPr>
         <p:spPr>
           <a:xfrm>
-            <a:off x="1168400" y="3089870"/>
-            <a:ext cx="533400" cy="224830"/>
+            <a:off x="1168400" y="2981920"/>
+            <a:ext cx="533400" cy="250230"/>
           </a:xfrm>
           <a:prstGeom prst="rect">
             <a:avLst/>
@@ -1382,7 +1387,7 @@
           <a:p>
             <a:pPr algn="l">
               <a:lnSpc>
-                <a:spcPts val="2136"/>
+                <a:spcPts val="2336"/>
               </a:lnSpc>
               <a:buNone/>
             </a:pPr>
@@ -1409,8 +1414,8 @@
         </p:nvSpPr>
         <p:spPr>
           <a:xfrm>
-            <a:off x="1168400" y="3453892"/>
-            <a:ext cx="2095500" cy="413258"/>
+            <a:off x="1168400" y="3434842"/>
+            <a:ext cx="2095500" cy="349758"/>
           </a:xfrm>
           <a:prstGeom prst="rect">
             <a:avLst/>
@@ -1425,7 +1430,7 @@
           <a:p>
             <a:pPr algn="l">
               <a:lnSpc>
-                <a:spcPts val="3346"/>
+                <a:spcPts val="2846"/>
               </a:lnSpc>
               <a:buNone/>
             </a:pPr>
@@ -1452,8 +1457,8 @@
         </p:nvSpPr>
         <p:spPr>
           <a:xfrm>
-            <a:off x="1168400" y="3991325"/>
-            <a:ext cx="2743200" cy="688625"/>
+            <a:off x="1168400" y="3960174"/>
+            <a:ext cx="2743200" cy="503876"/>
           </a:xfrm>
           <a:prstGeom prst="rect">
             <a:avLst/>
@@ -1468,7 +1473,7 @@
           <a:p>
             <a:pPr algn="l">
               <a:lnSpc>
-                <a:spcPts val="2559"/>
+                <a:spcPts val="1950"/>
               </a:lnSpc>
               <a:spcBef>
                 <a:spcPts val="0"/>
@@ -1501,7 +1506,7 @@
         </p:nvSpPr>
         <p:spPr>
           <a:xfrm>
-            <a:off x="4445000" y="2908300"/>
+            <a:off x="4445000" y="2825750"/>
             <a:ext cx="3302000" cy="2095500"/>
           </a:xfrm>
           <a:prstGeom prst="roundRect">
@@ -1525,8 +1530,8 @@
         </p:nvSpPr>
         <p:spPr>
           <a:xfrm>
-            <a:off x="4724400" y="3089870"/>
-            <a:ext cx="571500" cy="224830"/>
+            <a:off x="4724400" y="2981920"/>
+            <a:ext cx="571500" cy="250230"/>
           </a:xfrm>
           <a:prstGeom prst="rect">
             <a:avLst/>
@@ -1541,7 +1546,7 @@
           <a:p>
             <a:pPr algn="l">
               <a:lnSpc>
-                <a:spcPts val="2136"/>
+                <a:spcPts val="2336"/>
               </a:lnSpc>
               <a:buNone/>
             </a:pPr>
@@ -1568,8 +1573,8 @@
         </p:nvSpPr>
         <p:spPr>
           <a:xfrm>
-            <a:off x="4724400" y="3438252"/>
-            <a:ext cx="1974850" cy="352698"/>
+            <a:off x="4724400" y="3419202"/>
+            <a:ext cx="1974850" cy="289198"/>
           </a:xfrm>
           <a:prstGeom prst="rect">
             <a:avLst/>
@@ -1584,7 +1589,7 @@
           <a:p>
             <a:pPr algn="l">
               <a:lnSpc>
-                <a:spcPts val="3346"/>
+                <a:spcPts val="2846"/>
               </a:lnSpc>
               <a:buNone/>
             </a:pPr>
@@ -1611,8 +1616,8 @@
         </p:nvSpPr>
         <p:spPr>
           <a:xfrm>
-            <a:off x="4724400" y="3991325"/>
-            <a:ext cx="2743200" cy="1012475"/>
+            <a:off x="4724400" y="3960174"/>
+            <a:ext cx="2743200" cy="751526"/>
           </a:xfrm>
           <a:prstGeom prst="rect">
             <a:avLst/>
@@ -1627,7 +1632,7 @@
           <a:p>
             <a:pPr algn="l">
               <a:lnSpc>
-                <a:spcPts val="2559"/>
+                <a:spcPts val="1950"/>
               </a:lnSpc>
               <a:spcBef>
                 <a:spcPts val="0"/>
@@ -1660,7 +1665,7 @@
         </p:nvSpPr>
         <p:spPr>
           <a:xfrm>
-            <a:off x="8001000" y="2908300"/>
+            <a:off x="8001000" y="2825750"/>
             <a:ext cx="3302000" cy="2095500"/>
           </a:xfrm>
           <a:prstGeom prst="roundRect">
@@ -1684,8 +1689,8 @@
         </p:nvSpPr>
         <p:spPr>
           <a:xfrm>
-            <a:off x="8280400" y="3089870"/>
-            <a:ext cx="577850" cy="224830"/>
+            <a:off x="8280400" y="2981920"/>
+            <a:ext cx="577850" cy="250230"/>
           </a:xfrm>
           <a:prstGeom prst="rect">
             <a:avLst/>
@@ -1700,7 +1705,7 @@
           <a:p>
             <a:pPr algn="l">
               <a:lnSpc>
-                <a:spcPts val="2136"/>
+                <a:spcPts val="2336"/>
               </a:lnSpc>
               <a:buNone/>
             </a:pPr>
@@ -1727,8 +1732,8 @@
         </p:nvSpPr>
         <p:spPr>
           <a:xfrm>
-            <a:off x="8280400" y="3438252"/>
-            <a:ext cx="2266950" cy="352698"/>
+            <a:off x="8280400" y="3419202"/>
+            <a:ext cx="2266950" cy="289198"/>
           </a:xfrm>
           <a:prstGeom prst="rect">
             <a:avLst/>
@@ -1743,7 +1748,7 @@
           <a:p>
             <a:pPr algn="l">
               <a:lnSpc>
-                <a:spcPts val="3346"/>
+                <a:spcPts val="2846"/>
               </a:lnSpc>
               <a:buNone/>
             </a:pPr>
@@ -1770,8 +1775,8 @@
         </p:nvSpPr>
         <p:spPr>
           <a:xfrm>
-            <a:off x="8280400" y="3991325"/>
-            <a:ext cx="2743200" cy="1012475"/>
+            <a:off x="8280400" y="3960174"/>
+            <a:ext cx="2743200" cy="751526"/>
           </a:xfrm>
           <a:prstGeom prst="rect">
             <a:avLst/>
@@ -1786,7 +1791,7 @@
           <a:p>
             <a:pPr algn="l">
               <a:lnSpc>
-                <a:spcPts val="2559"/>
+                <a:spcPts val="1950"/>
               </a:lnSpc>
               <a:spcBef>
                 <a:spcPts val="0"/>
@@ -1903,8 +1908,8 @@
         </p:nvSpPr>
         <p:spPr>
           <a:xfrm>
-            <a:off x="11112500" y="6178804"/>
-            <a:ext cx="323850" cy="183896"/>
+            <a:off x="11112500" y="6185154"/>
+            <a:ext cx="323850" cy="177546"/>
           </a:xfrm>
           <a:prstGeom prst="rect">
             <a:avLst/>
@@ -1919,7 +1924,7 @@
           <a:p>
             <a:pPr algn="l">
               <a:lnSpc>
-                <a:spcPts val="1784"/>
+                <a:spcPts val="1734"/>
               </a:lnSpc>
               <a:buNone/>
             </a:pPr>
@@ -1946,8 +1951,8 @@
         </p:nvSpPr>
         <p:spPr>
           <a:xfrm>
-            <a:off x="889000" y="563537"/>
-            <a:ext cx="1492250" cy="198463"/>
+            <a:off x="889000" y="569887"/>
+            <a:ext cx="1492250" cy="192113"/>
           </a:xfrm>
           <a:prstGeom prst="rect">
             <a:avLst/>
@@ -1962,7 +1967,7 @@
           <a:p>
             <a:pPr algn="l">
               <a:lnSpc>
-                <a:spcPts val="1916"/>
+                <a:spcPts val="1866"/>
               </a:lnSpc>
               <a:buNone/>
             </a:pPr>
@@ -1993,8 +1998,8 @@
         </p:nvSpPr>
         <p:spPr>
           <a:xfrm>
-            <a:off x="889000" y="956604"/>
-            <a:ext cx="7993062" cy="1380196"/>
+            <a:off x="889000" y="1129260"/>
+            <a:ext cx="7993062" cy="1124990"/>
           </a:xfrm>
           <a:prstGeom prst="rect">
             <a:avLst/>
@@ -2009,7 +2014,7 @@
           <a:p>
             <a:pPr algn="l">
               <a:lnSpc>
-                <a:spcPts val="5543"/>
+                <a:spcPts val="4416"/>
               </a:lnSpc>
               <a:spcBef>
                 <a:spcPts val="0"/>
@@ -2035,7 +2040,7 @@
           <a:p>
             <a:pPr algn="l">
               <a:lnSpc>
-                <a:spcPts val="5543"/>
+                <a:spcPts val="4416"/>
               </a:lnSpc>
               <a:spcBef>
                 <a:spcPts val="0"/>
@@ -2079,10 +2084,10 @@
         </p:nvGrpSpPr>
         <p:grpSpPr>
           <a:xfrm>
-            <a:off x="6858000" y="2781300"/>
-            <a:ext cx="4445000" cy="3067050"/>
+            <a:off x="6858000" y="2698750"/>
+            <a:ext cx="4445000" cy="2787650"/>
             <a:chOff x="0" y="0"/>
-            <a:chExt cx="4445000" cy="3067050"/>
+            <a:chExt cx="4445000" cy="2787650"/>
           </a:xfrm>
         </p:grpSpPr>
         <p:sp>
@@ -2094,11 +2099,11 @@
           <p:spPr>
             <a:xfrm>
               <a:off x="12700" y="12700"/>
-              <a:ext cx="4419600" cy="3232150"/>
+              <a:ext cx="4419600" cy="2444750"/>
             </a:xfrm>
             <a:prstGeom prst="roundRect">
               <a:avLst>
-                <a:gd name="adj" fmla="val 3340"/>
+                <a:gd name="adj" fmla="val 4416"/>
               </a:avLst>
             </a:prstGeom>
             <a:solidFill>
@@ -2185,8 +2190,8 @@
           </p:nvSpPr>
           <p:spPr>
             <a:xfrm>
-              <a:off x="635000" y="57163"/>
-              <a:ext cx="1103312" cy="190487"/>
+              <a:off x="635000" y="82563"/>
+              <a:ext cx="1103312" cy="165087"/>
             </a:xfrm>
             <a:prstGeom prst="rect">
               <a:avLst/>
@@ -2201,7 +2206,7 @@
             <a:p>
               <a:pPr algn="l">
                 <a:lnSpc>
-                  <a:spcPts val="1586"/>
+                  <a:spcPts val="1386"/>
                 </a:lnSpc>
                 <a:buNone/>
               </a:pPr>
@@ -2228,8 +2233,8 @@
           </p:nvSpPr>
           <p:spPr>
             <a:xfrm>
-              <a:off x="177800" y="353759"/>
-              <a:ext cx="4089400" cy="2713292"/>
+              <a:off x="177800" y="417957"/>
+              <a:ext cx="4089400" cy="1861693"/>
             </a:xfrm>
             <a:prstGeom prst="rect">
               <a:avLst/>
@@ -2244,7 +2249,7 @@
             <a:p>
               <a:pPr algn="l">
                 <a:lnSpc>
-                  <a:spcPts val="2345"/>
+                  <a:spcPts val="1625"/>
                 </a:lnSpc>
                 <a:spcBef>
                   <a:spcPts val="0"/>
@@ -2270,7 +2275,7 @@
             <a:p>
               <a:pPr algn="l" marL="196850">
                 <a:lnSpc>
-                  <a:spcPts val="2345"/>
+                  <a:spcPts val="1625"/>
                 </a:lnSpc>
                 <a:spcBef>
                   <a:spcPts val="0"/>
@@ -2296,7 +2301,7 @@
             <a:p>
               <a:pPr algn="l" marL="393700">
                 <a:lnSpc>
-                  <a:spcPts val="2345"/>
+                  <a:spcPts val="1625"/>
                 </a:lnSpc>
                 <a:spcBef>
                   <a:spcPts val="0"/>
@@ -2355,7 +2360,7 @@
             <a:p>
               <a:pPr algn="l" marL="393700">
                 <a:lnSpc>
-                  <a:spcPts val="2345"/>
+                  <a:spcPts val="1625"/>
                 </a:lnSpc>
                 <a:spcBef>
                   <a:spcPts val="0"/>
@@ -2414,7 +2419,7 @@
             <a:p>
               <a:pPr algn="l" marL="393700">
                 <a:lnSpc>
-                  <a:spcPts val="2345"/>
+                  <a:spcPts val="1625"/>
                 </a:lnSpc>
                 <a:spcBef>
                   <a:spcPts val="0"/>
@@ -2473,7 +2478,7 @@
             <a:p>
               <a:pPr algn="l" marL="393700">
                 <a:lnSpc>
-                  <a:spcPts val="2345"/>
+                  <a:spcPts val="1625"/>
                 </a:lnSpc>
                 <a:spcBef>
                   <a:spcPts val="0"/>
@@ -2521,7 +2526,7 @@
             <a:p>
               <a:pPr algn="l" marL="196850">
                 <a:lnSpc>
-                  <a:spcPts val="2345"/>
+                  <a:spcPts val="1625"/>
                 </a:lnSpc>
                 <a:spcBef>
                   <a:spcPts val="0"/>
@@ -2547,7 +2552,7 @@
             <a:p>
               <a:pPr algn="l" marL="196850">
                 <a:lnSpc>
-                  <a:spcPts val="2345"/>
+                  <a:spcPts val="1625"/>
                 </a:lnSpc>
                 <a:spcBef>
                   <a:spcPts val="0"/>
@@ -2661,7 +2666,7 @@
             <a:p>
               <a:pPr algn="l">
                 <a:lnSpc>
-                  <a:spcPts val="2345"/>
+                  <a:spcPts val="1625"/>
                 </a:lnSpc>
                 <a:spcBef>
                   <a:spcPts val="0"/>
@@ -2695,7 +2700,7 @@
         </p:nvSpPr>
         <p:spPr>
           <a:xfrm>
-            <a:off x="889000" y="3111500"/>
+            <a:off x="889000" y="3028950"/>
             <a:ext cx="114300" cy="114300"/>
           </a:xfrm>
           <a:prstGeom prst="rect">
@@ -2717,8 +2722,8 @@
         </p:nvSpPr>
         <p:spPr>
           <a:xfrm>
-            <a:off x="1168400" y="2962988"/>
-            <a:ext cx="6992938" cy="281862"/>
+            <a:off x="1168400" y="2874088"/>
+            <a:ext cx="6992938" cy="288212"/>
           </a:xfrm>
           <a:prstGeom prst="rect">
             <a:avLst/>
@@ -2733,7 +2738,7 @@
           <a:p>
             <a:pPr algn="l">
               <a:lnSpc>
-                <a:spcPts val="2257"/>
+                <a:spcPts val="2307"/>
               </a:lnSpc>
               <a:buNone/>
             </a:pPr>
@@ -2760,7 +2765,7 @@
         </p:nvSpPr>
         <p:spPr>
           <a:xfrm>
-            <a:off x="889000" y="3746500"/>
+            <a:off x="889000" y="3663950"/>
             <a:ext cx="114300" cy="114300"/>
           </a:xfrm>
           <a:prstGeom prst="rect">
@@ -2782,8 +2787,8 @@
         </p:nvSpPr>
         <p:spPr>
           <a:xfrm>
-            <a:off x="1168400" y="3597988"/>
-            <a:ext cx="5842000" cy="281862"/>
+            <a:off x="1168400" y="3509088"/>
+            <a:ext cx="5842000" cy="288212"/>
           </a:xfrm>
           <a:prstGeom prst="rect">
             <a:avLst/>
@@ -2798,7 +2803,7 @@
           <a:p>
             <a:pPr algn="l">
               <a:lnSpc>
-                <a:spcPts val="2257"/>
+                <a:spcPts val="2307"/>
               </a:lnSpc>
               <a:buNone/>
             </a:pPr>
@@ -2825,7 +2830,7 @@
         </p:nvSpPr>
         <p:spPr>
           <a:xfrm>
-            <a:off x="889000" y="4381500"/>
+            <a:off x="889000" y="4298950"/>
             <a:ext cx="114300" cy="114300"/>
           </a:xfrm>
           <a:prstGeom prst="rect">
@@ -2847,8 +2852,8 @@
         </p:nvSpPr>
         <p:spPr>
           <a:xfrm>
-            <a:off x="1168400" y="4232988"/>
-            <a:ext cx="4429125" cy="281862"/>
+            <a:off x="1168400" y="4144088"/>
+            <a:ext cx="4429125" cy="288212"/>
           </a:xfrm>
           <a:prstGeom prst="rect">
             <a:avLst/>
@@ -2863,7 +2868,7 @@
           <a:p>
             <a:pPr algn="l">
               <a:lnSpc>
-                <a:spcPts val="2257"/>
+                <a:spcPts val="2307"/>
               </a:lnSpc>
               <a:buNone/>
             </a:pPr>
@@ -2890,7 +2895,7 @@
         </p:nvSpPr>
         <p:spPr>
           <a:xfrm>
-            <a:off x="889000" y="5016500"/>
+            <a:off x="889000" y="4933950"/>
             <a:ext cx="114300" cy="114300"/>
           </a:xfrm>
           <a:prstGeom prst="rect">
@@ -2912,8 +2917,8 @@
         </p:nvSpPr>
         <p:spPr>
           <a:xfrm>
-            <a:off x="1168400" y="4870202"/>
-            <a:ext cx="4929188" cy="279648"/>
+            <a:off x="1168400" y="4781302"/>
+            <a:ext cx="4929188" cy="285998"/>
           </a:xfrm>
           <a:prstGeom prst="rect">
             <a:avLst/>
@@ -2928,7 +2933,7 @@
           <a:p>
             <a:pPr algn="l">
               <a:lnSpc>
-                <a:spcPts val="2257"/>
+                <a:spcPts val="2307"/>
               </a:lnSpc>
               <a:buNone/>
             </a:pPr>
@@ -3039,8 +3044,8 @@
         </p:nvSpPr>
         <p:spPr>
           <a:xfrm>
-            <a:off x="11112500" y="6178804"/>
-            <a:ext cx="323850" cy="183896"/>
+            <a:off x="11112500" y="6185154"/>
+            <a:ext cx="323850" cy="177546"/>
           </a:xfrm>
           <a:prstGeom prst="rect">
             <a:avLst/>
@@ -3055,7 +3060,7 @@
           <a:p>
             <a:pPr algn="l">
               <a:lnSpc>
-                <a:spcPts val="1784"/>
+                <a:spcPts val="1734"/>
               </a:lnSpc>
               <a:buNone/>
             </a:pPr>
@@ -3082,8 +3087,8 @@
         </p:nvSpPr>
         <p:spPr>
           <a:xfrm>
-            <a:off x="889000" y="563537"/>
-            <a:ext cx="1492250" cy="198463"/>
+            <a:off x="889000" y="569887"/>
+            <a:ext cx="1492250" cy="192113"/>
           </a:xfrm>
           <a:prstGeom prst="rect">
             <a:avLst/>
@@ -3098,7 +3103,7 @@
           <a:p>
             <a:pPr algn="l">
               <a:lnSpc>
-                <a:spcPts val="1916"/>
+                <a:spcPts val="1866"/>
               </a:lnSpc>
               <a:buNone/>
             </a:pPr>
@@ -3129,8 +3134,8 @@
         </p:nvSpPr>
         <p:spPr>
           <a:xfrm>
-            <a:off x="889000" y="956604"/>
-            <a:ext cx="9350375" cy="675346"/>
+            <a:off x="889000" y="1129260"/>
+            <a:ext cx="9350375" cy="566190"/>
           </a:xfrm>
           <a:prstGeom prst="rect">
             <a:avLst/>
@@ -3145,7 +3150,7 @@
           <a:p>
             <a:pPr algn="l">
               <a:lnSpc>
-                <a:spcPts val="5543"/>
+                <a:spcPts val="4416"/>
               </a:lnSpc>
               <a:spcBef>
                 <a:spcPts val="0"/>
@@ -3189,7 +3194,7 @@
         </p:nvSpPr>
         <p:spPr>
           <a:xfrm>
-            <a:off x="889000" y="2393950"/>
+            <a:off x="889000" y="2457450"/>
             <a:ext cx="1981200" cy="1905000"/>
           </a:xfrm>
           <a:prstGeom prst="roundRect">
@@ -3213,8 +3218,8 @@
         </p:nvSpPr>
         <p:spPr>
           <a:xfrm>
-            <a:off x="1054100" y="2475390"/>
-            <a:ext cx="511175" cy="223360"/>
+            <a:off x="1054100" y="2519840"/>
+            <a:ext cx="511175" cy="242410"/>
           </a:xfrm>
           <a:prstGeom prst="rect">
             <a:avLst/>
@@ -3229,7 +3234,7 @@
           <a:p>
             <a:pPr algn="l">
               <a:lnSpc>
-                <a:spcPts val="2075"/>
+                <a:spcPts val="2225"/>
               </a:lnSpc>
               <a:buNone/>
             </a:pPr>
@@ -3256,8 +3261,8 @@
         </p:nvSpPr>
         <p:spPr>
           <a:xfrm>
-            <a:off x="1054100" y="2760896"/>
-            <a:ext cx="1409700" cy="353144"/>
+            <a:off x="1054100" y="2811696"/>
+            <a:ext cx="1409700" cy="365844"/>
           </a:xfrm>
           <a:prstGeom prst="rect">
             <a:avLst/>
@@ -3272,7 +3277,7 @@
           <a:p>
             <a:pPr algn="l">
               <a:lnSpc>
-                <a:spcPts val="2862"/>
+                <a:spcPts val="2962"/>
               </a:lnSpc>
               <a:buNone/>
             </a:pPr>
@@ -3299,8 +3304,8 @@
         </p:nvSpPr>
         <p:spPr>
           <a:xfrm>
-            <a:off x="1054100" y="3191790"/>
-            <a:ext cx="1651000" cy="561060"/>
+            <a:off x="1054100" y="3301489"/>
+            <a:ext cx="1651000" cy="406911"/>
           </a:xfrm>
           <a:prstGeom prst="rect">
             <a:avLst/>
@@ -3315,7 +3320,7 @@
           <a:p>
             <a:pPr algn="l">
               <a:lnSpc>
-                <a:spcPts val="2088"/>
+                <a:spcPts val="1560"/>
               </a:lnSpc>
               <a:spcBef>
                 <a:spcPts val="0"/>
@@ -3348,7 +3353,7 @@
         </p:nvSpPr>
         <p:spPr>
           <a:xfrm>
-            <a:off x="2895600" y="3289300"/>
+            <a:off x="2895600" y="3352800"/>
             <a:ext cx="76200" cy="114300"/>
           </a:xfrm>
           <a:custGeom>
@@ -3400,7 +3405,7 @@
         </p:nvSpPr>
         <p:spPr>
           <a:xfrm>
-            <a:off x="2997200" y="2393950"/>
+            <a:off x="2997200" y="2457450"/>
             <a:ext cx="1981200" cy="1905000"/>
           </a:xfrm>
           <a:prstGeom prst="roundRect">
@@ -3424,8 +3429,8 @@
         </p:nvSpPr>
         <p:spPr>
           <a:xfrm>
-            <a:off x="3162300" y="2475390"/>
-            <a:ext cx="555625" cy="223360"/>
+            <a:off x="3162300" y="2519840"/>
+            <a:ext cx="555625" cy="242410"/>
           </a:xfrm>
           <a:prstGeom prst="rect">
             <a:avLst/>
@@ -3440,7 +3445,7 @@
           <a:p>
             <a:pPr algn="l">
               <a:lnSpc>
-                <a:spcPts val="2075"/>
+                <a:spcPts val="2225"/>
               </a:lnSpc>
               <a:buNone/>
             </a:pPr>
@@ -3467,8 +3472,8 @@
         </p:nvSpPr>
         <p:spPr>
           <a:xfrm>
-            <a:off x="3162300" y="2760896"/>
-            <a:ext cx="1200150" cy="353144"/>
+            <a:off x="3162300" y="2811696"/>
+            <a:ext cx="1200150" cy="365844"/>
           </a:xfrm>
           <a:prstGeom prst="rect">
             <a:avLst/>
@@ -3483,7 +3488,7 @@
           <a:p>
             <a:pPr algn="l">
               <a:lnSpc>
-                <a:spcPts val="2862"/>
+                <a:spcPts val="2962"/>
               </a:lnSpc>
               <a:buNone/>
             </a:pPr>
@@ -3510,8 +3515,8 @@
         </p:nvSpPr>
         <p:spPr>
           <a:xfrm>
-            <a:off x="3162300" y="3191790"/>
-            <a:ext cx="1651000" cy="561060"/>
+            <a:off x="3162300" y="3301489"/>
+            <a:ext cx="1651000" cy="406911"/>
           </a:xfrm>
           <a:prstGeom prst="rect">
             <a:avLst/>
@@ -3526,7 +3531,7 @@
           <a:p>
             <a:pPr algn="l">
               <a:lnSpc>
-                <a:spcPts val="2088"/>
+                <a:spcPts val="1560"/>
               </a:lnSpc>
               <a:spcBef>
                 <a:spcPts val="0"/>
@@ -3559,7 +3564,7 @@
         </p:nvSpPr>
         <p:spPr>
           <a:xfrm>
-            <a:off x="5003800" y="3289300"/>
+            <a:off x="5003800" y="3352800"/>
             <a:ext cx="76200" cy="114300"/>
           </a:xfrm>
           <a:custGeom>
@@ -3611,7 +3616,7 @@
         </p:nvSpPr>
         <p:spPr>
           <a:xfrm>
-            <a:off x="5105400" y="2393950"/>
+            <a:off x="5105400" y="2457450"/>
             <a:ext cx="1981200" cy="1905000"/>
           </a:xfrm>
           <a:prstGeom prst="roundRect">
@@ -3635,8 +3640,8 @@
         </p:nvSpPr>
         <p:spPr>
           <a:xfrm>
-            <a:off x="5270500" y="2475390"/>
-            <a:ext cx="555625" cy="223360"/>
+            <a:off x="5270500" y="2519840"/>
+            <a:ext cx="555625" cy="242410"/>
           </a:xfrm>
           <a:prstGeom prst="rect">
             <a:avLst/>
@@ -3651,7 +3656,7 @@
           <a:p>
             <a:pPr algn="l">
               <a:lnSpc>
-                <a:spcPts val="2075"/>
+                <a:spcPts val="2225"/>
               </a:lnSpc>
               <a:buNone/>
             </a:pPr>
@@ -3678,8 +3683,8 @@
         </p:nvSpPr>
         <p:spPr>
           <a:xfrm>
-            <a:off x="5270500" y="2763624"/>
-            <a:ext cx="1276350" cy="299616"/>
+            <a:off x="5270500" y="2814424"/>
+            <a:ext cx="1276350" cy="312316"/>
           </a:xfrm>
           <a:prstGeom prst="rect">
             <a:avLst/>
@@ -3694,7 +3699,7 @@
           <a:p>
             <a:pPr algn="l">
               <a:lnSpc>
-                <a:spcPts val="2862"/>
+                <a:spcPts val="2962"/>
               </a:lnSpc>
               <a:buNone/>
             </a:pPr>
@@ -3721,8 +3726,8 @@
         </p:nvSpPr>
         <p:spPr>
           <a:xfrm>
-            <a:off x="5270500" y="3191790"/>
-            <a:ext cx="1651000" cy="561060"/>
+            <a:off x="5270500" y="3301489"/>
+            <a:ext cx="1651000" cy="406911"/>
           </a:xfrm>
           <a:prstGeom prst="rect">
             <a:avLst/>
@@ -3737,7 +3742,7 @@
           <a:p>
             <a:pPr algn="l">
               <a:lnSpc>
-                <a:spcPts val="2088"/>
+                <a:spcPts val="1560"/>
               </a:lnSpc>
               <a:spcBef>
                 <a:spcPts val="0"/>
@@ -3770,7 +3775,7 @@
         </p:nvSpPr>
         <p:spPr>
           <a:xfrm>
-            <a:off x="7112000" y="3289300"/>
+            <a:off x="7112000" y="3352800"/>
             <a:ext cx="76200" cy="114300"/>
           </a:xfrm>
           <a:custGeom>
@@ -3822,7 +3827,7 @@
         </p:nvSpPr>
         <p:spPr>
           <a:xfrm>
-            <a:off x="7213600" y="2393950"/>
+            <a:off x="7213600" y="2457450"/>
             <a:ext cx="1981200" cy="1905000"/>
           </a:xfrm>
           <a:prstGeom prst="roundRect">
@@ -3846,8 +3851,8 @@
         </p:nvSpPr>
         <p:spPr>
           <a:xfrm>
-            <a:off x="7378700" y="2475390"/>
-            <a:ext cx="561975" cy="223360"/>
+            <a:off x="7378700" y="2519840"/>
+            <a:ext cx="561975" cy="242410"/>
           </a:xfrm>
           <a:prstGeom prst="rect">
             <a:avLst/>
@@ -3862,7 +3867,7 @@
           <a:p>
             <a:pPr algn="l">
               <a:lnSpc>
-                <a:spcPts val="2075"/>
+                <a:spcPts val="2225"/>
               </a:lnSpc>
               <a:buNone/>
             </a:pPr>
@@ -3889,8 +3894,8 @@
         </p:nvSpPr>
         <p:spPr>
           <a:xfrm>
-            <a:off x="7378700" y="2774129"/>
-            <a:ext cx="1473200" cy="301811"/>
+            <a:off x="7378700" y="2824929"/>
+            <a:ext cx="1473200" cy="314511"/>
           </a:xfrm>
           <a:prstGeom prst="rect">
             <a:avLst/>
@@ -3905,7 +3910,7 @@
           <a:p>
             <a:pPr algn="l">
               <a:lnSpc>
-                <a:spcPts val="2862"/>
+                <a:spcPts val="2962"/>
               </a:lnSpc>
               <a:buNone/>
             </a:pPr>
@@ -3932,8 +3937,8 @@
         </p:nvSpPr>
         <p:spPr>
           <a:xfrm>
-            <a:off x="7378700" y="3191790"/>
-            <a:ext cx="1651000" cy="294360"/>
+            <a:off x="7378700" y="3301489"/>
+            <a:ext cx="1651000" cy="210061"/>
           </a:xfrm>
           <a:prstGeom prst="rect">
             <a:avLst/>
@@ -3948,7 +3953,7 @@
           <a:p>
             <a:pPr algn="l">
               <a:lnSpc>
-                <a:spcPts val="2088"/>
+                <a:spcPts val="1560"/>
               </a:lnSpc>
               <a:spcBef>
                 <a:spcPts val="0"/>
@@ -3981,7 +3986,7 @@
         </p:nvSpPr>
         <p:spPr>
           <a:xfrm>
-            <a:off x="9220200" y="3289300"/>
+            <a:off x="9220200" y="3352800"/>
             <a:ext cx="76200" cy="114300"/>
           </a:xfrm>
           <a:custGeom>
@@ -4033,7 +4038,7 @@
         </p:nvSpPr>
         <p:spPr>
           <a:xfrm>
-            <a:off x="9321800" y="2393950"/>
+            <a:off x="9321800" y="2457450"/>
             <a:ext cx="1981200" cy="1905000"/>
           </a:xfrm>
           <a:prstGeom prst="roundRect">
@@ -4057,8 +4062,8 @@
         </p:nvSpPr>
         <p:spPr>
           <a:xfrm>
-            <a:off x="9486900" y="2475390"/>
-            <a:ext cx="555625" cy="223360"/>
+            <a:off x="9486900" y="2519840"/>
+            <a:ext cx="555625" cy="242410"/>
           </a:xfrm>
           <a:prstGeom prst="rect">
             <a:avLst/>
@@ -4073,7 +4078,7 @@
           <a:p>
             <a:pPr algn="l">
               <a:lnSpc>
-                <a:spcPts val="2075"/>
+                <a:spcPts val="2225"/>
               </a:lnSpc>
               <a:buNone/>
             </a:pPr>
@@ -4100,8 +4105,8 @@
         </p:nvSpPr>
         <p:spPr>
           <a:xfrm>
-            <a:off x="9486900" y="2760896"/>
-            <a:ext cx="1295400" cy="353144"/>
+            <a:off x="9486900" y="2811696"/>
+            <a:ext cx="1295400" cy="365844"/>
           </a:xfrm>
           <a:prstGeom prst="rect">
             <a:avLst/>
@@ -4116,7 +4121,7 @@
           <a:p>
             <a:pPr algn="l">
               <a:lnSpc>
-                <a:spcPts val="2862"/>
+                <a:spcPts val="2962"/>
               </a:lnSpc>
               <a:buNone/>
             </a:pPr>
@@ -4143,8 +4148,8 @@
         </p:nvSpPr>
         <p:spPr>
           <a:xfrm>
-            <a:off x="9486900" y="3191790"/>
-            <a:ext cx="1651000" cy="561060"/>
+            <a:off x="9486900" y="3301489"/>
+            <a:ext cx="1651000" cy="406911"/>
           </a:xfrm>
           <a:prstGeom prst="rect">
             <a:avLst/>
@@ -4159,7 +4164,7 @@
           <a:p>
             <a:pPr algn="l">
               <a:lnSpc>
-                <a:spcPts val="2088"/>
+                <a:spcPts val="1560"/>
               </a:lnSpc>
               <a:spcBef>
                 <a:spcPts val="0"/>
@@ -4192,8 +4197,8 @@
         </p:nvSpPr>
         <p:spPr>
           <a:xfrm>
-            <a:off x="889000" y="4617670"/>
-            <a:ext cx="10414000" cy="729030"/>
+            <a:off x="889000" y="4734302"/>
+            <a:ext cx="10414000" cy="542548"/>
           </a:xfrm>
           <a:prstGeom prst="rect">
             <a:avLst/>
@@ -4208,7 +4213,7 @@
           <a:p>
             <a:pPr algn="l">
               <a:lnSpc>
-                <a:spcPts val="2717"/>
+                <a:spcPts val="2080"/>
               </a:lnSpc>
               <a:spcBef>
                 <a:spcPts val="0"/>
@@ -4325,8 +4330,8 @@
         </p:nvSpPr>
         <p:spPr>
           <a:xfrm>
-            <a:off x="11112500" y="6178804"/>
-            <a:ext cx="323850" cy="183896"/>
+            <a:off x="11112500" y="6185154"/>
+            <a:ext cx="323850" cy="177546"/>
           </a:xfrm>
           <a:prstGeom prst="rect">
             <a:avLst/>
@@ -4341,7 +4346,7 @@
           <a:p>
             <a:pPr algn="l">
               <a:lnSpc>
-                <a:spcPts val="1784"/>
+                <a:spcPts val="1734"/>
               </a:lnSpc>
               <a:buNone/>
             </a:pPr>
@@ -4368,8 +4373,8 @@
         </p:nvSpPr>
         <p:spPr>
           <a:xfrm>
-            <a:off x="889000" y="561886"/>
-            <a:ext cx="1738312" cy="200114"/>
+            <a:off x="889000" y="568236"/>
+            <a:ext cx="1738312" cy="193764"/>
           </a:xfrm>
           <a:prstGeom prst="rect">
             <a:avLst/>
@@ -4384,7 +4389,7 @@
           <a:p>
             <a:pPr algn="l">
               <a:lnSpc>
-                <a:spcPts val="1916"/>
+                <a:spcPts val="1866"/>
               </a:lnSpc>
               <a:buNone/>
             </a:pPr>
@@ -4415,8 +4420,8 @@
         </p:nvSpPr>
         <p:spPr>
           <a:xfrm>
-            <a:off x="889000" y="956604"/>
-            <a:ext cx="8310562" cy="675346"/>
+            <a:off x="889000" y="1129260"/>
+            <a:ext cx="8310562" cy="566190"/>
           </a:xfrm>
           <a:prstGeom prst="rect">
             <a:avLst/>
@@ -4431,7 +4436,7 @@
           <a:p>
             <a:pPr algn="l">
               <a:lnSpc>
-                <a:spcPts val="5543"/>
+                <a:spcPts val="4416"/>
               </a:lnSpc>
               <a:spcBef>
                 <a:spcPts val="0"/>
@@ -4475,7 +4480,7 @@
         </p:nvSpPr>
         <p:spPr>
           <a:xfrm>
-            <a:off x="889000" y="2076450"/>
+            <a:off x="889000" y="2139950"/>
             <a:ext cx="2470150" cy="1841500"/>
           </a:xfrm>
           <a:prstGeom prst="roundRect">
@@ -4507,7 +4512,7 @@
         </p:blipFill>
         <p:spPr>
           <a:xfrm>
-            <a:off x="889000" y="2076450"/>
+            <a:off x="889000" y="2139950"/>
             <a:ext cx="2470150" cy="1841500"/>
           </a:xfrm>
           <a:prstGeom prst="rect">
@@ -4523,7 +4528,7 @@
         </p:nvSpPr>
         <p:spPr>
           <a:xfrm>
-            <a:off x="3536950" y="2076450"/>
+            <a:off x="3536950" y="2139950"/>
             <a:ext cx="2470150" cy="1841500"/>
           </a:xfrm>
           <a:prstGeom prst="roundRect">
@@ -4555,7 +4560,7 @@
         </p:blipFill>
         <p:spPr>
           <a:xfrm>
-            <a:off x="3536950" y="2076450"/>
+            <a:off x="3536950" y="2139950"/>
             <a:ext cx="2470150" cy="1841500"/>
           </a:xfrm>
           <a:prstGeom prst="rect">
@@ -4571,7 +4576,7 @@
         </p:nvSpPr>
         <p:spPr>
           <a:xfrm>
-            <a:off x="6184900" y="2076450"/>
+            <a:off x="6184900" y="2139950"/>
             <a:ext cx="2470150" cy="1841500"/>
           </a:xfrm>
           <a:prstGeom prst="roundRect">
@@ -4603,7 +4608,7 @@
         </p:blipFill>
         <p:spPr>
           <a:xfrm>
-            <a:off x="6184900" y="2076450"/>
+            <a:off x="6184900" y="2139950"/>
             <a:ext cx="2470150" cy="1841500"/>
           </a:xfrm>
           <a:prstGeom prst="rect">
@@ -4619,7 +4624,7 @@
         </p:nvSpPr>
         <p:spPr>
           <a:xfrm>
-            <a:off x="8832850" y="2076450"/>
+            <a:off x="8832850" y="2139950"/>
             <a:ext cx="2470150" cy="1841500"/>
           </a:xfrm>
           <a:prstGeom prst="roundRect">
@@ -4651,7 +4656,7 @@
         </p:blipFill>
         <p:spPr>
           <a:xfrm>
-            <a:off x="8832850" y="2076450"/>
+            <a:off x="8832850" y="2139950"/>
             <a:ext cx="2470150" cy="1841500"/>
           </a:xfrm>
           <a:prstGeom prst="rect">
@@ -4667,7 +4672,7 @@
         </p:nvSpPr>
         <p:spPr>
           <a:xfrm>
-            <a:off x="889000" y="4095750"/>
+            <a:off x="889000" y="4159250"/>
             <a:ext cx="2470150" cy="1841500"/>
           </a:xfrm>
           <a:prstGeom prst="roundRect">
@@ -4699,7 +4704,7 @@
         </p:blipFill>
         <p:spPr>
           <a:xfrm>
-            <a:off x="889000" y="4095750"/>
+            <a:off x="889000" y="4159250"/>
             <a:ext cx="2470150" cy="1841500"/>
           </a:xfrm>
           <a:prstGeom prst="rect">
@@ -4715,7 +4720,7 @@
         </p:nvSpPr>
         <p:spPr>
           <a:xfrm>
-            <a:off x="3536950" y="4095750"/>
+            <a:off x="3536950" y="4159250"/>
             <a:ext cx="2470150" cy="1841500"/>
           </a:xfrm>
           <a:prstGeom prst="roundRect">
@@ -4747,7 +4752,7 @@
         </p:blipFill>
         <p:spPr>
           <a:xfrm>
-            <a:off x="3536950" y="4095750"/>
+            <a:off x="3536950" y="4159250"/>
             <a:ext cx="2470150" cy="1841500"/>
           </a:xfrm>
           <a:prstGeom prst="rect">
@@ -4763,7 +4768,7 @@
         </p:nvSpPr>
         <p:spPr>
           <a:xfrm>
-            <a:off x="6184900" y="4095750"/>
+            <a:off x="6184900" y="4159250"/>
             <a:ext cx="2470150" cy="1841500"/>
           </a:xfrm>
           <a:prstGeom prst="roundRect">
@@ -4795,7 +4800,7 @@
         </p:blipFill>
         <p:spPr>
           <a:xfrm>
-            <a:off x="6184900" y="4095750"/>
+            <a:off x="6184900" y="4159250"/>
             <a:ext cx="2470150" cy="1841500"/>
           </a:xfrm>
           <a:prstGeom prst="rect">
@@ -4811,7 +4816,7 @@
         </p:nvSpPr>
         <p:spPr>
           <a:xfrm>
-            <a:off x="8832850" y="4095750"/>
+            <a:off x="8832850" y="4159250"/>
             <a:ext cx="2470150" cy="1841500"/>
           </a:xfrm>
           <a:prstGeom prst="roundRect">
@@ -4843,7 +4848,7 @@
         </p:blipFill>
         <p:spPr>
           <a:xfrm>
-            <a:off x="8832850" y="4095750"/>
+            <a:off x="8832850" y="4159250"/>
             <a:ext cx="2470150" cy="1841500"/>
           </a:xfrm>
           <a:prstGeom prst="rect">
@@ -4859,7 +4864,7 @@
         </p:nvGrpSpPr>
         <p:grpSpPr>
           <a:xfrm>
-            <a:off x="977900" y="3549650"/>
+            <a:off x="977900" y="3613150"/>
             <a:ext cx="1022350" cy="266700"/>
             <a:chOff x="0" y="0"/>
             <a:chExt cx="1022350" cy="266700"/>
@@ -4899,8 +4904,8 @@
           </p:nvSpPr>
           <p:spPr>
             <a:xfrm>
-              <a:off x="114300" y="28804"/>
-              <a:ext cx="1003300" cy="193954"/>
+              <a:off x="114300" y="41504"/>
+              <a:ext cx="1003300" cy="181254"/>
             </a:xfrm>
             <a:prstGeom prst="rect">
               <a:avLst/>
@@ -4915,7 +4920,7 @@
             <a:p>
               <a:pPr algn="l">
                 <a:lnSpc>
-                  <a:spcPts val="1531"/>
+                  <a:spcPts val="1431"/>
                 </a:lnSpc>
                 <a:buNone/>
               </a:pPr>
@@ -4943,7 +4948,7 @@
         </p:nvGrpSpPr>
         <p:grpSpPr>
           <a:xfrm>
-            <a:off x="3625850" y="3549650"/>
+            <a:off x="3625850" y="3613150"/>
             <a:ext cx="1555750" cy="266700"/>
             <a:chOff x="0" y="0"/>
             <a:chExt cx="1555750" cy="266700"/>
@@ -4983,8 +4988,8 @@
           </p:nvSpPr>
           <p:spPr>
             <a:xfrm>
-              <a:off x="114300" y="28804"/>
-              <a:ext cx="1658938" cy="193954"/>
+              <a:off x="114300" y="41504"/>
+              <a:ext cx="1658938" cy="181254"/>
             </a:xfrm>
             <a:prstGeom prst="rect">
               <a:avLst/>
@@ -4999,7 +5004,7 @@
             <a:p>
               <a:pPr algn="l">
                 <a:lnSpc>
-                  <a:spcPts val="1531"/>
+                  <a:spcPts val="1431"/>
                 </a:lnSpc>
                 <a:buNone/>
               </a:pPr>
@@ -5027,7 +5032,7 @@
         </p:nvGrpSpPr>
         <p:grpSpPr>
           <a:xfrm>
-            <a:off x="6273800" y="3549650"/>
+            <a:off x="6273800" y="3613150"/>
             <a:ext cx="1219200" cy="266700"/>
             <a:chOff x="0" y="0"/>
             <a:chExt cx="1219200" cy="266700"/>
@@ -5067,8 +5072,8 @@
           </p:nvSpPr>
           <p:spPr>
             <a:xfrm>
-              <a:off x="114300" y="28804"/>
-              <a:ext cx="1238250" cy="193954"/>
+              <a:off x="114300" y="41504"/>
+              <a:ext cx="1238250" cy="181254"/>
             </a:xfrm>
             <a:prstGeom prst="rect">
               <a:avLst/>
@@ -5083,7 +5088,7 @@
             <a:p>
               <a:pPr algn="l">
                 <a:lnSpc>
-                  <a:spcPts val="1531"/>
+                  <a:spcPts val="1431"/>
                 </a:lnSpc>
                 <a:buNone/>
               </a:pPr>
@@ -5111,7 +5116,7 @@
         </p:nvGrpSpPr>
         <p:grpSpPr>
           <a:xfrm>
-            <a:off x="8921750" y="3549650"/>
+            <a:off x="8921750" y="3613150"/>
             <a:ext cx="1346200" cy="266700"/>
             <a:chOff x="0" y="0"/>
             <a:chExt cx="1346200" cy="266700"/>
@@ -5151,8 +5156,8 @@
           </p:nvSpPr>
           <p:spPr>
             <a:xfrm>
-              <a:off x="114300" y="28804"/>
-              <a:ext cx="1397000" cy="193954"/>
+              <a:off x="114300" y="41504"/>
+              <a:ext cx="1397000" cy="181254"/>
             </a:xfrm>
             <a:prstGeom prst="rect">
               <a:avLst/>
@@ -5167,7 +5172,7 @@
             <a:p>
               <a:pPr algn="l">
                 <a:lnSpc>
-                  <a:spcPts val="1531"/>
+                  <a:spcPts val="1431"/>
                 </a:lnSpc>
                 <a:buNone/>
               </a:pPr>
@@ -5195,7 +5200,7 @@
         </p:nvGrpSpPr>
         <p:grpSpPr>
           <a:xfrm>
-            <a:off x="977900" y="5568950"/>
+            <a:off x="977900" y="5632450"/>
             <a:ext cx="1600200" cy="266700"/>
             <a:chOff x="0" y="0"/>
             <a:chExt cx="1600200" cy="266700"/>
@@ -5235,8 +5240,8 @@
           </p:nvSpPr>
           <p:spPr>
             <a:xfrm>
-              <a:off x="114300" y="28804"/>
-              <a:ext cx="1714500" cy="168554"/>
+              <a:off x="114300" y="41504"/>
+              <a:ext cx="1714500" cy="155854"/>
             </a:xfrm>
             <a:prstGeom prst="rect">
               <a:avLst/>
@@ -5251,7 +5256,7 @@
             <a:p>
               <a:pPr algn="l">
                 <a:lnSpc>
-                  <a:spcPts val="1531"/>
+                  <a:spcPts val="1431"/>
                 </a:lnSpc>
                 <a:buNone/>
               </a:pPr>
@@ -5279,7 +5284,7 @@
         </p:nvGrpSpPr>
         <p:grpSpPr>
           <a:xfrm>
-            <a:off x="3625850" y="5568950"/>
+            <a:off x="3625850" y="5632450"/>
             <a:ext cx="1123950" cy="266700"/>
             <a:chOff x="0" y="0"/>
             <a:chExt cx="1123950" cy="266700"/>
@@ -5319,8 +5324,8 @@
           </p:nvSpPr>
           <p:spPr>
             <a:xfrm>
-              <a:off x="114300" y="28804"/>
-              <a:ext cx="1119188" cy="193954"/>
+              <a:off x="114300" y="41504"/>
+              <a:ext cx="1119188" cy="181254"/>
             </a:xfrm>
             <a:prstGeom prst="rect">
               <a:avLst/>
@@ -5335,7 +5340,7 @@
             <a:p>
               <a:pPr algn="l">
                 <a:lnSpc>
-                  <a:spcPts val="1531"/>
+                  <a:spcPts val="1431"/>
                 </a:lnSpc>
                 <a:buNone/>
               </a:pPr>
@@ -5363,7 +5368,7 @@
         </p:nvGrpSpPr>
         <p:grpSpPr>
           <a:xfrm>
-            <a:off x="6273800" y="5568950"/>
+            <a:off x="6273800" y="5632450"/>
             <a:ext cx="882650" cy="266700"/>
             <a:chOff x="0" y="0"/>
             <a:chExt cx="882650" cy="266700"/>
@@ -5403,8 +5408,8 @@
           </p:nvSpPr>
           <p:spPr>
             <a:xfrm>
-              <a:off x="114300" y="28804"/>
-              <a:ext cx="863600" cy="193954"/>
+              <a:off x="114300" y="41504"/>
+              <a:ext cx="863600" cy="181254"/>
             </a:xfrm>
             <a:prstGeom prst="rect">
               <a:avLst/>
@@ -5419,7 +5424,7 @@
             <a:p>
               <a:pPr algn="l">
                 <a:lnSpc>
-                  <a:spcPts val="1531"/>
+                  <a:spcPts val="1431"/>
                 </a:lnSpc>
                 <a:buNone/>
               </a:pPr>
@@ -5447,7 +5452,7 @@
         </p:nvGrpSpPr>
         <p:grpSpPr>
           <a:xfrm>
-            <a:off x="8921750" y="5568950"/>
+            <a:off x="8921750" y="5632450"/>
             <a:ext cx="1244600" cy="266700"/>
             <a:chOff x="0" y="0"/>
             <a:chExt cx="1244600" cy="266700"/>
@@ -5487,8 +5492,8 @@
           </p:nvSpPr>
           <p:spPr>
             <a:xfrm>
-              <a:off x="114300" y="28804"/>
-              <a:ext cx="1270000" cy="168554"/>
+              <a:off x="114300" y="41504"/>
+              <a:ext cx="1270000" cy="155854"/>
             </a:xfrm>
             <a:prstGeom prst="rect">
               <a:avLst/>
@@ -5503,7 +5508,7 @@
             <a:p>
               <a:pPr algn="l">
                 <a:lnSpc>
-                  <a:spcPts val="1531"/>
+                  <a:spcPts val="1431"/>
                 </a:lnSpc>
                 <a:buNone/>
               </a:pPr>
@@ -5615,8 +5620,8 @@
         </p:nvSpPr>
         <p:spPr>
           <a:xfrm>
-            <a:off x="11112500" y="6178804"/>
-            <a:ext cx="323850" cy="183896"/>
+            <a:off x="11112500" y="6185154"/>
+            <a:ext cx="323850" cy="177546"/>
           </a:xfrm>
           <a:prstGeom prst="rect">
             <a:avLst/>
@@ -5631,7 +5636,7 @@
           <a:p>
             <a:pPr algn="l">
               <a:lnSpc>
-                <a:spcPts val="1784"/>
+                <a:spcPts val="1734"/>
               </a:lnSpc>
               <a:buNone/>
             </a:pPr>
@@ -5658,8 +5663,8 @@
         </p:nvSpPr>
         <p:spPr>
           <a:xfrm>
-            <a:off x="889000" y="563537"/>
-            <a:ext cx="2603500" cy="198463"/>
+            <a:off x="889000" y="569887"/>
+            <a:ext cx="2603500" cy="192113"/>
           </a:xfrm>
           <a:prstGeom prst="rect">
             <a:avLst/>
@@ -5674,7 +5679,7 @@
           <a:p>
             <a:pPr algn="l">
               <a:lnSpc>
-                <a:spcPts val="1916"/>
+                <a:spcPts val="1866"/>
               </a:lnSpc>
               <a:buNone/>
             </a:pPr>
@@ -5701,8 +5706,8 @@
         </p:nvSpPr>
         <p:spPr>
           <a:xfrm>
-            <a:off x="889000" y="956604"/>
-            <a:ext cx="8080375" cy="675346"/>
+            <a:off x="889000" y="1129260"/>
+            <a:ext cx="8080375" cy="566190"/>
           </a:xfrm>
           <a:prstGeom prst="rect">
             <a:avLst/>
@@ -5717,7 +5722,7 @@
           <a:p>
             <a:pPr algn="l">
               <a:lnSpc>
-                <a:spcPts val="5543"/>
+                <a:spcPts val="4416"/>
               </a:lnSpc>
               <a:spcBef>
                 <a:spcPts val="0"/>
@@ -5761,7 +5766,7 @@
         </p:nvSpPr>
         <p:spPr>
           <a:xfrm>
-            <a:off x="889000" y="2203450"/>
+            <a:off x="889000" y="2266950"/>
             <a:ext cx="3302000" cy="2667000"/>
           </a:xfrm>
           <a:prstGeom prst="roundRect">
@@ -5785,8 +5790,8 @@
         </p:nvSpPr>
         <p:spPr>
           <a:xfrm>
-            <a:off x="1168400" y="2441389"/>
-            <a:ext cx="1460500" cy="301811"/>
+            <a:off x="1168400" y="2492189"/>
+            <a:ext cx="1460500" cy="314511"/>
           </a:xfrm>
           <a:prstGeom prst="rect">
             <a:avLst/>
@@ -5801,7 +5806,7 @@
           <a:p>
             <a:pPr algn="l">
               <a:lnSpc>
-                <a:spcPts val="2862"/>
+                <a:spcPts val="2962"/>
               </a:lnSpc>
               <a:buNone/>
             </a:pPr>
@@ -5828,7 +5833,7 @@
         </p:nvSpPr>
         <p:spPr>
           <a:xfrm>
-            <a:off x="1143000" y="2616200"/>
+            <a:off x="1143000" y="2679700"/>
             <a:ext cx="1092200" cy="25400"/>
           </a:xfrm>
           <a:prstGeom prst="rect">
@@ -5850,8 +5855,8 @@
         </p:nvSpPr>
         <p:spPr>
           <a:xfrm>
-            <a:off x="1168400" y="2740930"/>
-            <a:ext cx="2654300" cy="834120"/>
+            <a:off x="1168400" y="3001280"/>
+            <a:ext cx="2654300" cy="637270"/>
           </a:xfrm>
           <a:prstGeom prst="rect">
             <a:avLst/>
@@ -5866,7 +5871,7 @@
           <a:p>
             <a:pPr algn="l">
               <a:lnSpc>
-                <a:spcPts val="8065"/>
+                <a:spcPts val="6515"/>
               </a:lnSpc>
               <a:buNone/>
             </a:pPr>
@@ -5893,8 +5898,8 @@
         </p:nvSpPr>
         <p:spPr>
           <a:xfrm>
-            <a:off x="1168400" y="3987280"/>
-            <a:ext cx="2743200" cy="343420"/>
+            <a:off x="1168400" y="4100446"/>
+            <a:ext cx="2743200" cy="242954"/>
           </a:xfrm>
           <a:prstGeom prst="rect">
             <a:avLst/>
@@ -5909,7 +5914,7 @@
           <a:p>
             <a:pPr algn="l">
               <a:lnSpc>
-                <a:spcPts val="2402"/>
+                <a:spcPts val="1820"/>
               </a:lnSpc>
               <a:spcBef>
                 <a:spcPts val="0"/>
@@ -5942,7 +5947,7 @@
         </p:nvSpPr>
         <p:spPr>
           <a:xfrm>
-            <a:off x="4445000" y="2203450"/>
+            <a:off x="4445000" y="2266950"/>
             <a:ext cx="3302000" cy="2667000"/>
           </a:xfrm>
           <a:prstGeom prst="roundRect">
@@ -5966,8 +5971,8 @@
         </p:nvSpPr>
         <p:spPr>
           <a:xfrm>
-            <a:off x="4724400" y="2431295"/>
-            <a:ext cx="1066800" cy="305555"/>
+            <a:off x="4724400" y="2482095"/>
+            <a:ext cx="1066800" cy="318255"/>
           </a:xfrm>
           <a:prstGeom prst="rect">
             <a:avLst/>
@@ -5982,7 +5987,7 @@
           <a:p>
             <a:pPr algn="l">
               <a:lnSpc>
-                <a:spcPts val="2862"/>
+                <a:spcPts val="2962"/>
               </a:lnSpc>
               <a:buNone/>
             </a:pPr>
@@ -6009,7 +6014,7 @@
         </p:nvSpPr>
         <p:spPr>
           <a:xfrm>
-            <a:off x="4699000" y="2616200"/>
+            <a:off x="4699000" y="2679700"/>
             <a:ext cx="698500" cy="25400"/>
           </a:xfrm>
           <a:prstGeom prst="rect">
@@ -6031,8 +6036,8 @@
         </p:nvSpPr>
         <p:spPr>
           <a:xfrm>
-            <a:off x="4724400" y="2748992"/>
-            <a:ext cx="2971800" cy="838758"/>
+            <a:off x="4724400" y="3009342"/>
+            <a:ext cx="2971800" cy="641908"/>
           </a:xfrm>
           <a:prstGeom prst="rect">
             <a:avLst/>
@@ -6047,7 +6052,7 @@
           <a:p>
             <a:pPr algn="l">
               <a:lnSpc>
-                <a:spcPts val="8065"/>
+                <a:spcPts val="6515"/>
               </a:lnSpc>
               <a:buNone/>
             </a:pPr>
@@ -6074,8 +6079,8 @@
         </p:nvSpPr>
         <p:spPr>
           <a:xfrm>
-            <a:off x="4724400" y="3987280"/>
-            <a:ext cx="2743200" cy="343420"/>
+            <a:off x="4724400" y="4100446"/>
+            <a:ext cx="2743200" cy="242954"/>
           </a:xfrm>
           <a:prstGeom prst="rect">
             <a:avLst/>
@@ -6090,7 +6095,7 @@
           <a:p>
             <a:pPr algn="l">
               <a:lnSpc>
-                <a:spcPts val="2402"/>
+                <a:spcPts val="1820"/>
               </a:lnSpc>
               <a:spcBef>
                 <a:spcPts val="0"/>
@@ -6123,7 +6128,7 @@
         </p:nvSpPr>
         <p:spPr>
           <a:xfrm>
-            <a:off x="8001000" y="2203450"/>
+            <a:off x="8001000" y="2266950"/>
             <a:ext cx="3302000" cy="2667000"/>
           </a:xfrm>
           <a:prstGeom prst="roundRect">
@@ -6147,8 +6152,8 @@
         </p:nvSpPr>
         <p:spPr>
           <a:xfrm>
-            <a:off x="8280400" y="2430884"/>
-            <a:ext cx="1162050" cy="299616"/>
+            <a:off x="8280400" y="2481684"/>
+            <a:ext cx="1162050" cy="312316"/>
           </a:xfrm>
           <a:prstGeom prst="rect">
             <a:avLst/>
@@ -6163,7 +6168,7 @@
           <a:p>
             <a:pPr algn="l">
               <a:lnSpc>
-                <a:spcPts val="2862"/>
+                <a:spcPts val="2962"/>
               </a:lnSpc>
               <a:buNone/>
             </a:pPr>
@@ -6190,7 +6195,7 @@
         </p:nvSpPr>
         <p:spPr>
           <a:xfrm>
-            <a:off x="8255000" y="2616200"/>
+            <a:off x="8255000" y="2679700"/>
             <a:ext cx="793750" cy="25400"/>
           </a:xfrm>
           <a:prstGeom prst="rect">
@@ -6212,8 +6217,8 @@
         </p:nvSpPr>
         <p:spPr>
           <a:xfrm>
-            <a:off x="8280400" y="2748992"/>
-            <a:ext cx="3162300" cy="838758"/>
+            <a:off x="8280400" y="3009342"/>
+            <a:ext cx="3162300" cy="641908"/>
           </a:xfrm>
           <a:prstGeom prst="rect">
             <a:avLst/>
@@ -6228,7 +6233,7 @@
           <a:p>
             <a:pPr algn="l">
               <a:lnSpc>
-                <a:spcPts val="8065"/>
+                <a:spcPts val="6515"/>
               </a:lnSpc>
               <a:buNone/>
             </a:pPr>
@@ -6255,8 +6260,8 @@
         </p:nvSpPr>
         <p:spPr>
           <a:xfrm>
-            <a:off x="8280400" y="3987280"/>
-            <a:ext cx="2743200" cy="648220"/>
+            <a:off x="8280400" y="4100446"/>
+            <a:ext cx="2743200" cy="471554"/>
           </a:xfrm>
           <a:prstGeom prst="rect">
             <a:avLst/>
@@ -6271,7 +6276,7 @@
           <a:p>
             <a:pPr algn="l">
               <a:lnSpc>
-                <a:spcPts val="2402"/>
+                <a:spcPts val="1820"/>
               </a:lnSpc>
               <a:spcBef>
                 <a:spcPts val="0"/>
@@ -6304,8 +6309,8 @@
         </p:nvSpPr>
         <p:spPr>
           <a:xfrm>
-            <a:off x="889000" y="5066780"/>
-            <a:ext cx="10414000" cy="648220"/>
+            <a:off x="889000" y="5179946"/>
+            <a:ext cx="10414000" cy="471554"/>
           </a:xfrm>
           <a:prstGeom prst="rect">
             <a:avLst/>
@@ -6320,7 +6325,7 @@
           <a:p>
             <a:pPr algn="l">
               <a:lnSpc>
-                <a:spcPts val="2402"/>
+                <a:spcPts val="1820"/>
               </a:lnSpc>
               <a:spcBef>
                 <a:spcPts val="0"/>
@@ -6437,8 +6442,8 @@
         </p:nvSpPr>
         <p:spPr>
           <a:xfrm>
-            <a:off x="11112500" y="6178804"/>
-            <a:ext cx="323850" cy="183896"/>
+            <a:off x="11112500" y="6185154"/>
+            <a:ext cx="323850" cy="177546"/>
           </a:xfrm>
           <a:prstGeom prst="rect">
             <a:avLst/>
@@ -6453,7 +6458,7 @@
           <a:p>
             <a:pPr algn="l">
               <a:lnSpc>
-                <a:spcPts val="1784"/>
+                <a:spcPts val="1734"/>
               </a:lnSpc>
               <a:buNone/>
             </a:pPr>
@@ -6480,8 +6485,8 @@
         </p:nvSpPr>
         <p:spPr>
           <a:xfrm>
-            <a:off x="889000" y="563537"/>
-            <a:ext cx="1238250" cy="198463"/>
+            <a:off x="889000" y="569887"/>
+            <a:ext cx="1238250" cy="192113"/>
           </a:xfrm>
           <a:prstGeom prst="rect">
             <a:avLst/>
@@ -6496,7 +6501,7 @@
           <a:p>
             <a:pPr algn="l">
               <a:lnSpc>
-                <a:spcPts val="1916"/>
+                <a:spcPts val="1866"/>
               </a:lnSpc>
               <a:buNone/>
             </a:pPr>
@@ -6527,8 +6532,8 @@
         </p:nvSpPr>
         <p:spPr>
           <a:xfrm>
-            <a:off x="889000" y="956604"/>
-            <a:ext cx="8445500" cy="675346"/>
+            <a:off x="889000" y="1129260"/>
+            <a:ext cx="8445500" cy="566190"/>
           </a:xfrm>
           <a:prstGeom prst="rect">
             <a:avLst/>
@@ -6543,7 +6548,7 @@
           <a:p>
             <a:pPr algn="l">
               <a:lnSpc>
-                <a:spcPts val="5543"/>
+                <a:spcPts val="4416"/>
               </a:lnSpc>
               <a:spcBef>
                 <a:spcPts val="0"/>
@@ -6587,7 +6592,7 @@
         </p:nvSpPr>
         <p:spPr>
           <a:xfrm>
-            <a:off x="889000" y="2203450"/>
+            <a:off x="889000" y="2266950"/>
             <a:ext cx="2463800" cy="2667000"/>
           </a:xfrm>
           <a:prstGeom prst="roundRect">
@@ -6611,8 +6616,8 @@
         </p:nvSpPr>
         <p:spPr>
           <a:xfrm>
-            <a:off x="1143000" y="2337991"/>
-            <a:ext cx="1530350" cy="424259"/>
+            <a:off x="1143000" y="2471341"/>
+            <a:ext cx="1530350" cy="354409"/>
           </a:xfrm>
           <a:prstGeom prst="rect">
             <a:avLst/>
@@ -6627,7 +6632,7 @@
           <a:p>
             <a:pPr algn="l">
               <a:lnSpc>
-                <a:spcPts val="4072"/>
+                <a:spcPts val="3522"/>
               </a:lnSpc>
               <a:buNone/>
             </a:pPr>
@@ -6654,8 +6659,8 @@
         </p:nvSpPr>
         <p:spPr>
           <a:xfrm>
-            <a:off x="1143000" y="3100375"/>
-            <a:ext cx="1955800" cy="322275"/>
+            <a:off x="1143000" y="3222498"/>
+            <a:ext cx="1955800" cy="200152"/>
           </a:xfrm>
           <a:prstGeom prst="rect">
             <a:avLst/>
@@ -6670,7 +6675,7 @@
           <a:p>
             <a:pPr algn="l">
               <a:lnSpc>
-                <a:spcPts val="2259"/>
+                <a:spcPts val="1560"/>
               </a:lnSpc>
               <a:spcBef>
                 <a:spcPts val="0"/>
@@ -6703,8 +6708,8 @@
         </p:nvSpPr>
         <p:spPr>
           <a:xfrm>
-            <a:off x="1143000" y="3733280"/>
-            <a:ext cx="1955800" cy="648220"/>
+            <a:off x="1143000" y="3846446"/>
+            <a:ext cx="1955800" cy="471554"/>
           </a:xfrm>
           <a:prstGeom prst="rect">
             <a:avLst/>
@@ -6719,7 +6724,7 @@
           <a:p>
             <a:pPr algn="l">
               <a:lnSpc>
-                <a:spcPts val="2402"/>
+                <a:spcPts val="1820"/>
               </a:lnSpc>
               <a:spcBef>
                 <a:spcPts val="0"/>
@@ -6752,7 +6757,7 @@
         </p:nvSpPr>
         <p:spPr>
           <a:xfrm>
-            <a:off x="3543300" y="2203450"/>
+            <a:off x="3543300" y="2266950"/>
             <a:ext cx="2463800" cy="2667000"/>
           </a:xfrm>
           <a:prstGeom prst="roundRect">
@@ -6776,8 +6781,8 @@
         </p:nvSpPr>
         <p:spPr>
           <a:xfrm>
-            <a:off x="3797300" y="2337991"/>
-            <a:ext cx="1231900" cy="424259"/>
+            <a:off x="3797300" y="2471341"/>
+            <a:ext cx="1231900" cy="354409"/>
           </a:xfrm>
           <a:prstGeom prst="rect">
             <a:avLst/>
@@ -6792,7 +6797,7 @@
           <a:p>
             <a:pPr algn="l">
               <a:lnSpc>
-                <a:spcPts val="4072"/>
+                <a:spcPts val="3522"/>
               </a:lnSpc>
               <a:buNone/>
             </a:pPr>
@@ -6819,8 +6824,8 @@
         </p:nvSpPr>
         <p:spPr>
           <a:xfrm>
-            <a:off x="3797300" y="3100375"/>
-            <a:ext cx="1955800" cy="608025"/>
+            <a:off x="3797300" y="3222498"/>
+            <a:ext cx="1955800" cy="397002"/>
           </a:xfrm>
           <a:prstGeom prst="rect">
             <a:avLst/>
@@ -6835,7 +6840,7 @@
           <a:p>
             <a:pPr algn="l">
               <a:lnSpc>
-                <a:spcPts val="2259"/>
+                <a:spcPts val="1560"/>
               </a:lnSpc>
               <a:spcBef>
                 <a:spcPts val="0"/>
@@ -6868,8 +6873,8 @@
         </p:nvSpPr>
         <p:spPr>
           <a:xfrm>
-            <a:off x="3797300" y="3733280"/>
-            <a:ext cx="1955800" cy="648220"/>
+            <a:off x="3797300" y="3846446"/>
+            <a:ext cx="1955800" cy="471554"/>
           </a:xfrm>
           <a:prstGeom prst="rect">
             <a:avLst/>
@@ -6884,7 +6889,7 @@
           <a:p>
             <a:pPr algn="l">
               <a:lnSpc>
-                <a:spcPts val="2402"/>
+                <a:spcPts val="1820"/>
               </a:lnSpc>
               <a:spcBef>
                 <a:spcPts val="0"/>
@@ -6917,7 +6922,7 @@
         </p:nvSpPr>
         <p:spPr>
           <a:xfrm>
-            <a:off x="6191250" y="2203450"/>
+            <a:off x="6191250" y="2266950"/>
             <a:ext cx="2463800" cy="2667000"/>
           </a:xfrm>
           <a:prstGeom prst="roundRect">
@@ -6941,8 +6946,8 @@
         </p:nvSpPr>
         <p:spPr>
           <a:xfrm>
-            <a:off x="6445250" y="2334022"/>
-            <a:ext cx="1987550" cy="504428"/>
+            <a:off x="6445250" y="2467372"/>
+            <a:ext cx="1987550" cy="434578"/>
           </a:xfrm>
           <a:prstGeom prst="rect">
             <a:avLst/>
@@ -6957,7 +6962,7 @@
           <a:p>
             <a:pPr algn="l">
               <a:lnSpc>
-                <a:spcPts val="4072"/>
+                <a:spcPts val="3522"/>
               </a:lnSpc>
               <a:buNone/>
             </a:pPr>
@@ -6984,8 +6989,8 @@
         </p:nvSpPr>
         <p:spPr>
           <a:xfrm>
-            <a:off x="6445250" y="3100375"/>
-            <a:ext cx="1955800" cy="608025"/>
+            <a:off x="6445250" y="3222498"/>
+            <a:ext cx="1955800" cy="397002"/>
           </a:xfrm>
           <a:prstGeom prst="rect">
             <a:avLst/>
@@ -7000,7 +7005,7 @@
           <a:p>
             <a:pPr algn="l">
               <a:lnSpc>
-                <a:spcPts val="2259"/>
+                <a:spcPts val="1560"/>
               </a:lnSpc>
               <a:spcBef>
                 <a:spcPts val="0"/>
@@ -7033,8 +7038,8 @@
         </p:nvSpPr>
         <p:spPr>
           <a:xfrm>
-            <a:off x="6445250" y="3733280"/>
-            <a:ext cx="1955800" cy="953020"/>
+            <a:off x="6445250" y="3846446"/>
+            <a:ext cx="1955800" cy="706504"/>
           </a:xfrm>
           <a:prstGeom prst="rect">
             <a:avLst/>
@@ -7049,7 +7054,7 @@
           <a:p>
             <a:pPr algn="l">
               <a:lnSpc>
-                <a:spcPts val="2402"/>
+                <a:spcPts val="1820"/>
               </a:lnSpc>
               <a:spcBef>
                 <a:spcPts val="0"/>
@@ -7082,7 +7087,7 @@
         </p:nvSpPr>
         <p:spPr>
           <a:xfrm>
-            <a:off x="8839200" y="2203450"/>
+            <a:off x="8839200" y="2266950"/>
             <a:ext cx="2463800" cy="2667000"/>
           </a:xfrm>
           <a:prstGeom prst="roundRect">
@@ -7106,8 +7111,8 @@
         </p:nvSpPr>
         <p:spPr>
           <a:xfrm>
-            <a:off x="9093200" y="2337991"/>
-            <a:ext cx="1631950" cy="424259"/>
+            <a:off x="9093200" y="2471341"/>
+            <a:ext cx="1631950" cy="354409"/>
           </a:xfrm>
           <a:prstGeom prst="rect">
             <a:avLst/>
@@ -7122,7 +7127,7 @@
           <a:p>
             <a:pPr algn="l">
               <a:lnSpc>
-                <a:spcPts val="4072"/>
+                <a:spcPts val="3522"/>
               </a:lnSpc>
               <a:buNone/>
             </a:pPr>
@@ -7149,8 +7154,8 @@
         </p:nvSpPr>
         <p:spPr>
           <a:xfrm>
-            <a:off x="9093200" y="3100375"/>
-            <a:ext cx="1955800" cy="322275"/>
+            <a:off x="9093200" y="3222498"/>
+            <a:ext cx="1955800" cy="200152"/>
           </a:xfrm>
           <a:prstGeom prst="rect">
             <a:avLst/>
@@ -7165,7 +7170,7 @@
           <a:p>
             <a:pPr algn="l">
               <a:lnSpc>
-                <a:spcPts val="2259"/>
+                <a:spcPts val="1560"/>
               </a:lnSpc>
               <a:spcBef>
                 <a:spcPts val="0"/>
@@ -7198,8 +7203,8 @@
         </p:nvSpPr>
         <p:spPr>
           <a:xfrm>
-            <a:off x="9093200" y="3733280"/>
-            <a:ext cx="1955800" cy="648220"/>
+            <a:off x="9093200" y="3846446"/>
+            <a:ext cx="1955800" cy="471554"/>
           </a:xfrm>
           <a:prstGeom prst="rect">
             <a:avLst/>
@@ -7214,7 +7219,7 @@
           <a:p>
             <a:pPr algn="l">
               <a:lnSpc>
-                <a:spcPts val="2402"/>
+                <a:spcPts val="1820"/>
               </a:lnSpc>
               <a:spcBef>
                 <a:spcPts val="0"/>
@@ -7331,8 +7336,8 @@
         </p:nvSpPr>
         <p:spPr>
           <a:xfrm>
-            <a:off x="11112500" y="6180480"/>
-            <a:ext cx="323850" cy="188570"/>
+            <a:off x="11112500" y="6186830"/>
+            <a:ext cx="323850" cy="182220"/>
           </a:xfrm>
           <a:prstGeom prst="rect">
             <a:avLst/>
@@ -7347,7 +7352,7 @@
           <a:p>
             <a:pPr algn="l">
               <a:lnSpc>
-                <a:spcPts val="1784"/>
+                <a:spcPts val="1734"/>
               </a:lnSpc>
               <a:buNone/>
             </a:pPr>
@@ -7374,8 +7379,8 @@
         </p:nvSpPr>
         <p:spPr>
           <a:xfrm>
-            <a:off x="889000" y="563537"/>
-            <a:ext cx="946150" cy="198463"/>
+            <a:off x="889000" y="569887"/>
+            <a:ext cx="946150" cy="192113"/>
           </a:xfrm>
           <a:prstGeom prst="rect">
             <a:avLst/>
@@ -7390,7 +7395,7 @@
           <a:p>
             <a:pPr algn="l">
               <a:lnSpc>
-                <a:spcPts val="1916"/>
+                <a:spcPts val="1866"/>
               </a:lnSpc>
               <a:buNone/>
             </a:pPr>
@@ -7421,8 +7426,8 @@
         </p:nvSpPr>
         <p:spPr>
           <a:xfrm>
-            <a:off x="889000" y="956604"/>
-            <a:ext cx="9366250" cy="675346"/>
+            <a:off x="889000" y="1129260"/>
+            <a:ext cx="9366250" cy="566190"/>
           </a:xfrm>
           <a:prstGeom prst="rect">
             <a:avLst/>
@@ -7437,7 +7442,7 @@
           <a:p>
             <a:pPr algn="l">
               <a:lnSpc>
-                <a:spcPts val="5543"/>
+                <a:spcPts val="4416"/>
               </a:lnSpc>
               <a:spcBef>
                 <a:spcPts val="0"/>
@@ -7481,7 +7486,7 @@
         </p:nvSpPr>
         <p:spPr>
           <a:xfrm>
-            <a:off x="889000" y="2203450"/>
+            <a:off x="889000" y="2266950"/>
             <a:ext cx="2470150" cy="762000"/>
           </a:xfrm>
           <a:prstGeom prst="roundRect">
@@ -7505,8 +7510,8 @@
         </p:nvSpPr>
         <p:spPr>
           <a:xfrm>
-            <a:off x="1117600" y="2347863"/>
-            <a:ext cx="908050" cy="274687"/>
+            <a:off x="1117600" y="2398663"/>
+            <a:ext cx="908050" cy="287387"/>
           </a:xfrm>
           <a:prstGeom prst="rect">
             <a:avLst/>
@@ -7521,7 +7526,7 @@
           <a:p>
             <a:pPr algn="l">
               <a:lnSpc>
-                <a:spcPts val="2620"/>
+                <a:spcPts val="2720"/>
               </a:lnSpc>
               <a:buNone/>
             </a:pPr>
@@ -7548,7 +7553,7 @@
         </p:nvSpPr>
         <p:spPr>
           <a:xfrm>
-            <a:off x="3536950" y="2203450"/>
+            <a:off x="3536950" y="2266950"/>
             <a:ext cx="2470150" cy="762000"/>
           </a:xfrm>
           <a:prstGeom prst="roundRect">
@@ -7572,8 +7577,8 @@
         </p:nvSpPr>
         <p:spPr>
           <a:xfrm>
-            <a:off x="3765550" y="2347863"/>
-            <a:ext cx="1022350" cy="274687"/>
+            <a:off x="3765550" y="2398663"/>
+            <a:ext cx="1022350" cy="287387"/>
           </a:xfrm>
           <a:prstGeom prst="rect">
             <a:avLst/>
@@ -7588,7 +7593,7 @@
           <a:p>
             <a:pPr algn="l">
               <a:lnSpc>
-                <a:spcPts val="2620"/>
+                <a:spcPts val="2720"/>
               </a:lnSpc>
               <a:buNone/>
             </a:pPr>
@@ -7615,7 +7620,7 @@
         </p:nvSpPr>
         <p:spPr>
           <a:xfrm>
-            <a:off x="6184900" y="2203450"/>
+            <a:off x="6184900" y="2266950"/>
             <a:ext cx="2470150" cy="762000"/>
           </a:xfrm>
           <a:prstGeom prst="roundRect">
@@ -7639,8 +7644,8 @@
         </p:nvSpPr>
         <p:spPr>
           <a:xfrm>
-            <a:off x="6413500" y="2345382"/>
-            <a:ext cx="1117600" cy="277168"/>
+            <a:off x="6413500" y="2396182"/>
+            <a:ext cx="1117600" cy="289868"/>
           </a:xfrm>
           <a:prstGeom prst="rect">
             <a:avLst/>
@@ -7655,7 +7660,7 @@
           <a:p>
             <a:pPr algn="l">
               <a:lnSpc>
-                <a:spcPts val="2620"/>
+                <a:spcPts val="2720"/>
               </a:lnSpc>
               <a:buNone/>
             </a:pPr>
@@ -7682,7 +7687,7 @@
         </p:nvSpPr>
         <p:spPr>
           <a:xfrm>
-            <a:off x="8832850" y="2203450"/>
+            <a:off x="8832850" y="2266950"/>
             <a:ext cx="2470150" cy="762000"/>
           </a:xfrm>
           <a:prstGeom prst="roundRect">
@@ -7706,8 +7711,8 @@
         </p:nvSpPr>
         <p:spPr>
           <a:xfrm>
-            <a:off x="9061450" y="2345382"/>
-            <a:ext cx="895350" cy="277168"/>
+            <a:off x="9061450" y="2396182"/>
+            <a:ext cx="895350" cy="289868"/>
           </a:xfrm>
           <a:prstGeom prst="rect">
             <a:avLst/>
@@ -7722,7 +7727,7 @@
           <a:p>
             <a:pPr algn="l">
               <a:lnSpc>
-                <a:spcPts val="2620"/>
+                <a:spcPts val="2720"/>
               </a:lnSpc>
               <a:buNone/>
             </a:pPr>
@@ -7749,7 +7754,7 @@
         </p:nvSpPr>
         <p:spPr>
           <a:xfrm>
-            <a:off x="889000" y="3117850"/>
+            <a:off x="889000" y="3181350"/>
             <a:ext cx="2470150" cy="762000"/>
           </a:xfrm>
           <a:prstGeom prst="roundRect">
@@ -7773,8 +7778,8 @@
         </p:nvSpPr>
         <p:spPr>
           <a:xfrm>
-            <a:off x="1117600" y="3259782"/>
-            <a:ext cx="946150" cy="277168"/>
+            <a:off x="1117600" y="3310582"/>
+            <a:ext cx="946150" cy="289868"/>
           </a:xfrm>
           <a:prstGeom prst="rect">
             <a:avLst/>
@@ -7789,7 +7794,7 @@
           <a:p>
             <a:pPr algn="l">
               <a:lnSpc>
-                <a:spcPts val="2620"/>
+                <a:spcPts val="2720"/>
               </a:lnSpc>
               <a:buNone/>
             </a:pPr>
@@ -7816,7 +7821,7 @@
         </p:nvSpPr>
         <p:spPr>
           <a:xfrm>
-            <a:off x="3536950" y="3117850"/>
+            <a:off x="3536950" y="3181350"/>
             <a:ext cx="2470150" cy="762000"/>
           </a:xfrm>
           <a:prstGeom prst="roundRect">
@@ -7840,8 +7845,8 @@
         </p:nvSpPr>
         <p:spPr>
           <a:xfrm>
-            <a:off x="3765550" y="3262263"/>
-            <a:ext cx="908050" cy="274687"/>
+            <a:off x="3765550" y="3313063"/>
+            <a:ext cx="908050" cy="287387"/>
           </a:xfrm>
           <a:prstGeom prst="rect">
             <a:avLst/>
@@ -7856,7 +7861,7 @@
           <a:p>
             <a:pPr algn="l">
               <a:lnSpc>
-                <a:spcPts val="2620"/>
+                <a:spcPts val="2720"/>
               </a:lnSpc>
               <a:buNone/>
             </a:pPr>
@@ -7883,7 +7888,7 @@
         </p:nvSpPr>
         <p:spPr>
           <a:xfrm>
-            <a:off x="6184900" y="3117850"/>
+            <a:off x="6184900" y="3181350"/>
             <a:ext cx="2470150" cy="762000"/>
           </a:xfrm>
           <a:prstGeom prst="roundRect">
@@ -7907,8 +7912,8 @@
         </p:nvSpPr>
         <p:spPr>
           <a:xfrm>
-            <a:off x="6413500" y="3259782"/>
-            <a:ext cx="863600" cy="277168"/>
+            <a:off x="6413500" y="3310582"/>
+            <a:ext cx="863600" cy="289868"/>
           </a:xfrm>
           <a:prstGeom prst="rect">
             <a:avLst/>
@@ -7923,7 +7928,7 @@
           <a:p>
             <a:pPr algn="l">
               <a:lnSpc>
-                <a:spcPts val="2620"/>
+                <a:spcPts val="2720"/>
               </a:lnSpc>
               <a:buNone/>
             </a:pPr>
@@ -7950,7 +7955,7 @@
         </p:nvSpPr>
         <p:spPr>
           <a:xfrm>
-            <a:off x="8832850" y="3117850"/>
+            <a:off x="8832850" y="3181350"/>
             <a:ext cx="2470150" cy="762000"/>
           </a:xfrm>
           <a:prstGeom prst="roundRect">
@@ -7974,8 +7979,8 @@
         </p:nvSpPr>
         <p:spPr>
           <a:xfrm>
-            <a:off x="9061450" y="3259782"/>
-            <a:ext cx="1047750" cy="277168"/>
+            <a:off x="9061450" y="3310582"/>
+            <a:ext cx="1047750" cy="289868"/>
           </a:xfrm>
           <a:prstGeom prst="rect">
             <a:avLst/>
@@ -7990,7 +7995,7 @@
           <a:p>
             <a:pPr algn="l">
               <a:lnSpc>
-                <a:spcPts val="2620"/>
+                <a:spcPts val="2720"/>
               </a:lnSpc>
               <a:buNone/>
             </a:pPr>
@@ -8017,7 +8022,7 @@
         </p:nvSpPr>
         <p:spPr>
           <a:xfrm>
-            <a:off x="889000" y="4032250"/>
+            <a:off x="889000" y="4095750"/>
             <a:ext cx="2470150" cy="762000"/>
           </a:xfrm>
           <a:prstGeom prst="roundRect">
@@ -8041,8 +8046,8 @@
         </p:nvSpPr>
         <p:spPr>
           <a:xfrm>
-            <a:off x="1117600" y="4174182"/>
-            <a:ext cx="1098550" cy="277168"/>
+            <a:off x="1117600" y="4224982"/>
+            <a:ext cx="1098550" cy="289868"/>
           </a:xfrm>
           <a:prstGeom prst="rect">
             <a:avLst/>
@@ -8057,7 +8062,7 @@
           <a:p>
             <a:pPr algn="l">
               <a:lnSpc>
-                <a:spcPts val="2620"/>
+                <a:spcPts val="2720"/>
               </a:lnSpc>
               <a:buNone/>
             </a:pPr>
@@ -8084,7 +8089,7 @@
         </p:nvSpPr>
         <p:spPr>
           <a:xfrm>
-            <a:off x="3536950" y="4032250"/>
+            <a:off x="3536950" y="4095750"/>
             <a:ext cx="2470150" cy="762000"/>
           </a:xfrm>
           <a:prstGeom prst="roundRect">
@@ -8108,8 +8113,8 @@
         </p:nvSpPr>
         <p:spPr>
           <a:xfrm>
-            <a:off x="3765550" y="4176663"/>
-            <a:ext cx="825500" cy="274687"/>
+            <a:off x="3765550" y="4227463"/>
+            <a:ext cx="825500" cy="287387"/>
           </a:xfrm>
           <a:prstGeom prst="rect">
             <a:avLst/>
@@ -8124,7 +8129,7 @@
           <a:p>
             <a:pPr algn="l">
               <a:lnSpc>
-                <a:spcPts val="2620"/>
+                <a:spcPts val="2720"/>
               </a:lnSpc>
               <a:buNone/>
             </a:pPr>
@@ -8151,7 +8156,7 @@
         </p:nvSpPr>
         <p:spPr>
           <a:xfrm>
-            <a:off x="6184900" y="4032250"/>
+            <a:off x="6184900" y="4095750"/>
             <a:ext cx="2470150" cy="762000"/>
           </a:xfrm>
           <a:prstGeom prst="roundRect">
@@ -8175,8 +8180,8 @@
         </p:nvSpPr>
         <p:spPr>
           <a:xfrm>
-            <a:off x="6413500" y="4176663"/>
-            <a:ext cx="781050" cy="274687"/>
+            <a:off x="6413500" y="4227463"/>
+            <a:ext cx="781050" cy="287387"/>
           </a:xfrm>
           <a:prstGeom prst="rect">
             <a:avLst/>
@@ -8191,7 +8196,7 @@
           <a:p>
             <a:pPr algn="l">
               <a:lnSpc>
-                <a:spcPts val="2620"/>
+                <a:spcPts val="2720"/>
               </a:lnSpc>
               <a:buNone/>
             </a:pPr>
@@ -8218,7 +8223,7 @@
         </p:nvSpPr>
         <p:spPr>
           <a:xfrm>
-            <a:off x="8832850" y="4032250"/>
+            <a:off x="8832850" y="4095750"/>
             <a:ext cx="2470150" cy="762000"/>
           </a:xfrm>
           <a:prstGeom prst="roundRect">
@@ -8242,8 +8247,8 @@
         </p:nvSpPr>
         <p:spPr>
           <a:xfrm>
-            <a:off x="9061450" y="4174182"/>
-            <a:ext cx="939800" cy="277168"/>
+            <a:off x="9061450" y="4224982"/>
+            <a:ext cx="939800" cy="289868"/>
           </a:xfrm>
           <a:prstGeom prst="rect">
             <a:avLst/>
@@ -8258,7 +8263,7 @@
           <a:p>
             <a:pPr algn="l">
               <a:lnSpc>
-                <a:spcPts val="2620"/>
+                <a:spcPts val="2720"/>
               </a:lnSpc>
               <a:buNone/>
             </a:pPr>
@@ -8285,7 +8290,7 @@
         </p:nvSpPr>
         <p:spPr>
           <a:xfrm>
-            <a:off x="889000" y="4946650"/>
+            <a:off x="889000" y="5010150"/>
             <a:ext cx="2470150" cy="762000"/>
           </a:xfrm>
           <a:prstGeom prst="roundRect">
@@ -8309,8 +8314,8 @@
         </p:nvSpPr>
         <p:spPr>
           <a:xfrm>
-            <a:off x="1117600" y="5091063"/>
-            <a:ext cx="1149350" cy="274687"/>
+            <a:off x="1117600" y="5141863"/>
+            <a:ext cx="1149350" cy="287387"/>
           </a:xfrm>
           <a:prstGeom prst="rect">
             <a:avLst/>
@@ -8325,7 +8330,7 @@
           <a:p>
             <a:pPr algn="l">
               <a:lnSpc>
-                <a:spcPts val="2620"/>
+                <a:spcPts val="2720"/>
               </a:lnSpc>
               <a:buNone/>
             </a:pPr>
@@ -8352,7 +8357,7 @@
         </p:nvSpPr>
         <p:spPr>
           <a:xfrm>
-            <a:off x="3536950" y="4946650"/>
+            <a:off x="3536950" y="5010150"/>
             <a:ext cx="2470150" cy="762000"/>
           </a:xfrm>
           <a:prstGeom prst="roundRect">
@@ -8376,8 +8381,8 @@
         </p:nvSpPr>
         <p:spPr>
           <a:xfrm>
-            <a:off x="3765550" y="5088582"/>
-            <a:ext cx="1162050" cy="277168"/>
+            <a:off x="3765550" y="5139382"/>
+            <a:ext cx="1162050" cy="289868"/>
           </a:xfrm>
           <a:prstGeom prst="rect">
             <a:avLst/>
@@ -8392,7 +8397,7 @@
           <a:p>
             <a:pPr algn="l">
               <a:lnSpc>
-                <a:spcPts val="2620"/>
+                <a:spcPts val="2720"/>
               </a:lnSpc>
               <a:buNone/>
             </a:pPr>
@@ -8419,7 +8424,7 @@
         </p:nvSpPr>
         <p:spPr>
           <a:xfrm>
-            <a:off x="6184900" y="4946650"/>
+            <a:off x="6184900" y="5010150"/>
             <a:ext cx="2470150" cy="762000"/>
           </a:xfrm>
           <a:prstGeom prst="roundRect">
@@ -8443,8 +8448,8 @@
         </p:nvSpPr>
         <p:spPr>
           <a:xfrm>
-            <a:off x="6413500" y="5091063"/>
-            <a:ext cx="1098550" cy="274687"/>
+            <a:off x="6413500" y="5141863"/>
+            <a:ext cx="1098550" cy="287387"/>
           </a:xfrm>
           <a:prstGeom prst="rect">
             <a:avLst/>
@@ -8459,7 +8464,7 @@
           <a:p>
             <a:pPr algn="l">
               <a:lnSpc>
-                <a:spcPts val="2620"/>
+                <a:spcPts val="2720"/>
               </a:lnSpc>
               <a:buNone/>
             </a:pPr>
@@ -8486,7 +8491,7 @@
         </p:nvSpPr>
         <p:spPr>
           <a:xfrm>
-            <a:off x="8832850" y="4946650"/>
+            <a:off x="8832850" y="5010150"/>
             <a:ext cx="2470150" cy="762000"/>
           </a:xfrm>
           <a:prstGeom prst="roundRect">
@@ -8510,8 +8515,8 @@
         </p:nvSpPr>
         <p:spPr>
           <a:xfrm>
-            <a:off x="9061450" y="5100613"/>
-            <a:ext cx="1695450" cy="277837"/>
+            <a:off x="9061450" y="5151413"/>
+            <a:ext cx="1695450" cy="290537"/>
           </a:xfrm>
           <a:prstGeom prst="rect">
             <a:avLst/>
@@ -8526,7 +8531,7 @@
           <a:p>
             <a:pPr algn="l">
               <a:lnSpc>
-                <a:spcPts val="2620"/>
+                <a:spcPts val="2720"/>
               </a:lnSpc>
               <a:buNone/>
             </a:pPr>
@@ -8602,9 +8607,14 @@
                   <a:alpha val="40000"/>
                 </a:srgbClr>
               </a:gs>
-              <a:gs pos="60000">
+              <a:gs pos="42426">
                 <a:srgbClr val="3575EE">
                   <a:alpha val="6275"/>
+                </a:srgbClr>
+              </a:gs>
+              <a:gs pos="70711">
+                <a:srgbClr val="3575EE">
+                  <a:alpha val="0"/>
                 </a:srgbClr>
               </a:gs>
               <a:gs pos="100000">
@@ -8658,8 +8668,8 @@
         </p:nvSpPr>
         <p:spPr>
           <a:xfrm>
-            <a:off x="889000" y="1279021"/>
-            <a:ext cx="6627812" cy="1603879"/>
+            <a:off x="889000" y="1476220"/>
+            <a:ext cx="6627812" cy="1311430"/>
           </a:xfrm>
           <a:prstGeom prst="rect">
             <a:avLst/>
@@ -8674,7 +8684,7 @@
           <a:p>
             <a:pPr algn="l">
               <a:lnSpc>
-                <a:spcPts val="6434"/>
+                <a:spcPts val="5152"/>
               </a:lnSpc>
               <a:spcBef>
                 <a:spcPts val="0"/>
@@ -8700,7 +8710,7 @@
           <a:p>
             <a:pPr algn="l">
               <a:lnSpc>
-                <a:spcPts val="6434"/>
+                <a:spcPts val="5152"/>
               </a:lnSpc>
               <a:spcBef>
                 <a:spcPts val="0"/>
@@ -8733,7 +8743,7 @@
         </p:nvGrpSpPr>
         <p:grpSpPr>
           <a:xfrm>
-            <a:off x="889000" y="3390900"/>
+            <a:off x="889000" y="3295650"/>
             <a:ext cx="8255000" cy="1130300"/>
             <a:chOff x="0" y="0"/>
             <a:chExt cx="8255000" cy="1130300"/>
@@ -8748,11 +8758,11 @@
           <p:spPr>
             <a:xfrm>
               <a:off x="12700" y="12700"/>
-              <a:ext cx="8229600" cy="1225550"/>
+              <a:ext cx="8229600" cy="1066800"/>
             </a:xfrm>
             <a:prstGeom prst="roundRect">
               <a:avLst>
-                <a:gd name="adj" fmla="val 8808"/>
+                <a:gd name="adj" fmla="val 10119"/>
               </a:avLst>
             </a:prstGeom>
             <a:solidFill>
@@ -8839,8 +8849,8 @@
           </p:nvSpPr>
           <p:spPr>
             <a:xfrm>
-              <a:off x="635000" y="52629"/>
-              <a:ext cx="965200" cy="188671"/>
+              <a:off x="635000" y="58979"/>
+              <a:ext cx="965200" cy="182321"/>
             </a:xfrm>
             <a:prstGeom prst="rect">
               <a:avLst/>
@@ -8855,7 +8865,7 @@
             <a:p>
               <a:pPr algn="l">
                 <a:lnSpc>
-                  <a:spcPts val="1784"/>
+                  <a:spcPts val="1734"/>
                 </a:lnSpc>
                 <a:buNone/>
               </a:pPr>
@@ -8882,8 +8892,8 @@
           </p:nvSpPr>
           <p:spPr>
             <a:xfrm>
-              <a:off x="177800" y="349568"/>
-              <a:ext cx="7899400" cy="710882"/>
+              <a:off x="177800" y="419735"/>
+              <a:ext cx="7899400" cy="481965"/>
             </a:xfrm>
             <a:prstGeom prst="rect">
               <a:avLst/>
@@ -8898,7 +8908,7 @@
             <a:p>
               <a:pPr algn="l">
                 <a:lnSpc>
-                  <a:spcPts val="2675"/>
+                  <a:spcPts val="1875"/>
                 </a:lnSpc>
                 <a:spcBef>
                   <a:spcPts val="0"/>
@@ -8935,7 +8945,7 @@
             <a:p>
               <a:pPr algn="l">
                 <a:lnSpc>
-                  <a:spcPts val="2675"/>
+                  <a:spcPts val="1875"/>
                 </a:lnSpc>
                 <a:spcBef>
                   <a:spcPts val="0"/>
@@ -9004,8 +9014,8 @@
         </p:nvSpPr>
         <p:spPr>
           <a:xfrm>
-            <a:off x="3175000" y="5768340"/>
-            <a:ext cx="4572000" cy="334010"/>
+            <a:off x="3175000" y="5787390"/>
+            <a:ext cx="4572000" cy="314960"/>
           </a:xfrm>
           <a:prstGeom prst="rect">
             <a:avLst/>
@@ -9020,7 +9030,7 @@
           <a:p>
             <a:pPr algn="l">
               <a:lnSpc>
-                <a:spcPts val="2840"/>
+                <a:spcPts val="2690"/>
               </a:lnSpc>
               <a:buNone/>
             </a:pPr>

</xml_diff>